<commit_message>
feat: upgrade Marimekko and chart correctness gates
</commit_message>
<xml_diff>
--- a/builder/assets/reference-pages/chart-insight.pptx
+++ b/builder/assets/reference-pages/chart-insight.pptx
@@ -2,13 +2,13 @@
 <file path=ppt/presentation.xml><?xml version="1.0" encoding="utf-8"?>
 <p:presentation xmlns:p="http://schemas.openxmlformats.org/presentationml/2006/main">
   <p:sldMasterIdLst>
-    <p:sldMasterId xmlns:r="http://schemas.openxmlformats.org/officeDocument/2006/relationships" id="2147483648" r:id="R43a636a5f3404596"/>
+    <p:sldMasterId xmlns:r="http://schemas.openxmlformats.org/officeDocument/2006/relationships" id="2147483648" r:id="Ra205413e12594e9e"/>
   </p:sldMasterIdLst>
   <p:notesMasterIdLst>
-    <p:notesMasterId xmlns:r="http://schemas.openxmlformats.org/officeDocument/2006/relationships" r:id="Rc4a58343270e4322"/>
+    <p:notesMasterId xmlns:r="http://schemas.openxmlformats.org/officeDocument/2006/relationships" r:id="Rcf2f7886553f4d4b"/>
   </p:notesMasterIdLst>
   <p:sldIdLst>
-    <p:sldId xmlns:r="http://schemas.openxmlformats.org/officeDocument/2006/relationships" id="256" r:id="Rd78d4eab41774a29"/>
+    <p:sldId xmlns:r="http://schemas.openxmlformats.org/officeDocument/2006/relationships" id="256" r:id="R0c2033164a054833"/>
   </p:sldIdLst>
   <p:sldSz cx="12192000" cy="6858000"/>
   <p:notesSz cx="6858000" cy="9144000"/>
@@ -506,7 +506,7 @@
   </p:cSld>
   <p:clrMap bg1="lt1" tx1="dk1" bg2="lt2" tx2="dk2" accent1="accent1" accent2="accent2" accent3="accent3" accent4="accent4" accent5="accent5" accent6="accent6" hlink="hlink" folHlink="folHlink"/>
   <p:sldLayoutIdLst>
-    <p:sldLayoutId xmlns:r="http://schemas.openxmlformats.org/officeDocument/2006/relationships" id="2147483649" r:id="Rc2315bc4d1f246d4"/>
+    <p:sldLayoutId xmlns:r="http://schemas.openxmlformats.org/officeDocument/2006/relationships" id="2147483649" r:id="R159b738d7a3c48c5"/>
   </p:sldLayoutIdLst>
   <p:txStyles>
     <p:titleStyle>
@@ -1054,10 +1054,10 @@
       </p:grpSpPr>
       <p:sp>
         <p:nvSpPr>
-          <p:cNvPr id="59" name="page-title">
-            <a:extLst xmlns:a="http://schemas.openxmlformats.org/drawingml/2006/main">
-              <a:ext uri="{FF2B5EF4-FFF2-40B4-BE49-F238E27FC236}">
-                <a16:creationId xmlns:a16="http://schemas.microsoft.com/office/drawing/2014/main" id="{BBEBE138-DF1F-403E-B257-F85976722DF1}"/>
+          <p:cNvPr id="65" name="page-title">
+            <a:extLst xmlns:a="http://schemas.openxmlformats.org/drawingml/2006/main">
+              <a:ext uri="{FF2B5EF4-FFF2-40B4-BE49-F238E27FC236}">
+                <a16:creationId xmlns:a16="http://schemas.microsoft.com/office/drawing/2014/main" id="{A30ED9F9-0240-44DF-BB1B-B935CB5B1280}"/>
               </a:ext>
             </a:extLst>
           </p:cNvPr>
@@ -1081,18 +1081,20 @@
           </a:ln>
         </p:spPr>
         <p:txBody>
-          <a:bodyPr xmlns:a="http://schemas.openxmlformats.org/drawingml/2006/main" anchor="ctr"/>
+          <a:bodyPr xmlns:a="http://schemas.openxmlformats.org/drawingml/2006/main" wrap="square" lIns="38100" tIns="19050" rIns="38100" bIns="19050" anchor="ctr">
+            <a:noAutofit/>
+          </a:bodyPr>
           <a:lstStyle xmlns:a="http://schemas.openxmlformats.org/drawingml/2006/main"/>
           <a:p xmlns:a="http://schemas.openxmlformats.org/drawingml/2006/main">
             <a:pPr algn="l">
-              <a:defRPr sz="2550" b="1">
+              <a:defRPr sz="3000" b="1">
                 <a:solidFill>
                   <a:srgbClr val="15375F"/>
                 </a:solidFill>
               </a:defRPr>
             </a:pPr>
             <a:r>
-              <a:rPr sz="2550" b="1">
+              <a:rPr sz="3000" b="1">
                 <a:solidFill>
                   <a:srgbClr val="15375F"/>
                 </a:solidFill>
@@ -1107,7 +1109,7 @@
           <p:cNvPr id="2" name="chart-frame">
             <a:extLst xmlns:a="http://schemas.openxmlformats.org/drawingml/2006/main">
               <a:ext uri="{FF2B5EF4-FFF2-40B4-BE49-F238E27FC236}">
-                <a16:creationId xmlns:a16="http://schemas.microsoft.com/office/drawing/2014/main" id="{C252EC65-F2FF-45A0-BED0-8AA25A03626D}"/>
+                <a16:creationId xmlns:a16="http://schemas.microsoft.com/office/drawing/2014/main" id="{8990AE91-D6C0-467C-B000-904504436050}"/>
               </a:ext>
             </a:extLst>
           </p:cNvPr>
@@ -1121,10 +1123,8 @@
             <a:off x="590550" y="1428750"/>
             <a:ext cx="7239000" cy="3905250"/>
           </a:xfrm>
-          <a:prstGeom xmlns:a="http://schemas.openxmlformats.org/drawingml/2006/main" prst="roundRect">
-            <a:avLst>
-              <a:gd name="adj" fmla="val 1951"/>
-            </a:avLst>
+          <a:prstGeom xmlns:a="http://schemas.openxmlformats.org/drawingml/2006/main" prst="rect">
+            <a:avLst/>
           </a:prstGeom>
           <a:solidFill xmlns:a="http://schemas.openxmlformats.org/drawingml/2006/main">
             <a:srgbClr val="FFFFFF"/>
@@ -1142,7 +1142,7 @@
           <p:cNvPr id="3" name="grid-0">
             <a:extLst xmlns:a="http://schemas.openxmlformats.org/drawingml/2006/main">
               <a:ext uri="{FF2B5EF4-FFF2-40B4-BE49-F238E27FC236}">
-                <a16:creationId xmlns:a16="http://schemas.microsoft.com/office/drawing/2014/main" id="{B57AA870-442C-49E8-A63D-FBD42B893B76}"/>
+                <a16:creationId xmlns:a16="http://schemas.microsoft.com/office/drawing/2014/main" id="{08A01AD4-3146-45E0-A9D9-B4280E8BF47C}"/>
               </a:ext>
             </a:extLst>
           </p:cNvPr>
@@ -1173,7 +1173,7 @@
           <p:cNvPr id="4" name="grid-1">
             <a:extLst xmlns:a="http://schemas.openxmlformats.org/drawingml/2006/main">
               <a:ext uri="{FF2B5EF4-FFF2-40B4-BE49-F238E27FC236}">
-                <a16:creationId xmlns:a16="http://schemas.microsoft.com/office/drawing/2014/main" id="{0C7CF161-51A4-46B4-A25E-14D16BD2D493}"/>
+                <a16:creationId xmlns:a16="http://schemas.microsoft.com/office/drawing/2014/main" id="{C2CAA7CD-D2F4-4AD1-8A72-D7AA23643472}"/>
               </a:ext>
             </a:extLst>
           </p:cNvPr>
@@ -1204,7 +1204,7 @@
           <p:cNvPr id="5" name="grid-2">
             <a:extLst xmlns:a="http://schemas.openxmlformats.org/drawingml/2006/main">
               <a:ext uri="{FF2B5EF4-FFF2-40B4-BE49-F238E27FC236}">
-                <a16:creationId xmlns:a16="http://schemas.microsoft.com/office/drawing/2014/main" id="{3BF96147-5BF8-439B-9697-7026BAB727A0}"/>
+                <a16:creationId xmlns:a16="http://schemas.microsoft.com/office/drawing/2014/main" id="{485C0A37-4062-431C-A7B9-EF43ECBFD9B5}"/>
               </a:ext>
             </a:extLst>
           </p:cNvPr>
@@ -1235,7 +1235,7 @@
           <p:cNvPr id="6" name="grid-3">
             <a:extLst xmlns:a="http://schemas.openxmlformats.org/drawingml/2006/main">
               <a:ext uri="{FF2B5EF4-FFF2-40B4-BE49-F238E27FC236}">
-                <a16:creationId xmlns:a16="http://schemas.microsoft.com/office/drawing/2014/main" id="{4351A220-044C-49F2-ACB3-BFEF4F14F9D0}"/>
+                <a16:creationId xmlns:a16="http://schemas.microsoft.com/office/drawing/2014/main" id="{E019CA58-63EC-40F3-8FF5-BC932CABDC4B}"/>
               </a:ext>
             </a:extLst>
           </p:cNvPr>
@@ -1266,7 +1266,7 @@
           <p:cNvPr id="7" name="grid-4">
             <a:extLst xmlns:a="http://schemas.openxmlformats.org/drawingml/2006/main">
               <a:ext uri="{FF2B5EF4-FFF2-40B4-BE49-F238E27FC236}">
-                <a16:creationId xmlns:a16="http://schemas.microsoft.com/office/drawing/2014/main" id="{7E8D390E-473C-494B-8206-DD609B32675C}"/>
+                <a16:creationId xmlns:a16="http://schemas.microsoft.com/office/drawing/2014/main" id="{7C3B5CAC-59F8-454D-831B-BF2C51AD5376}"/>
               </a:ext>
             </a:extLst>
           </p:cNvPr>
@@ -1297,7 +1297,7 @@
           <p:cNvPr id="8" name="bar-1-1">
             <a:extLst xmlns:a="http://schemas.openxmlformats.org/drawingml/2006/main">
               <a:ext uri="{FF2B5EF4-FFF2-40B4-BE49-F238E27FC236}">
-                <a16:creationId xmlns:a16="http://schemas.microsoft.com/office/drawing/2014/main" id="{2706C5C5-C256-4674-A7FD-7262C6E09BF8}"/>
+                <a16:creationId xmlns:a16="http://schemas.microsoft.com/office/drawing/2014/main" id="{6CBF61EE-7829-4185-8CD4-355E09BB24C8}"/>
               </a:ext>
             </a:extLst>
           </p:cNvPr>
@@ -1330,7 +1330,7 @@
           <p:cNvPr id="9" name="bar-label-1-1">
             <a:extLst xmlns:a="http://schemas.openxmlformats.org/drawingml/2006/main">
               <a:ext uri="{FF2B5EF4-FFF2-40B4-BE49-F238E27FC236}">
-                <a16:creationId xmlns:a16="http://schemas.microsoft.com/office/drawing/2014/main" id="{2A62956B-1706-4571-943E-9A570A4312BB}"/>
+                <a16:creationId xmlns:a16="http://schemas.microsoft.com/office/drawing/2014/main" id="{C3274C8E-BC26-4BEE-B365-449C8EE65F12}"/>
               </a:ext>
             </a:extLst>
           </p:cNvPr>
@@ -1354,7 +1354,9 @@
           </a:ln>
         </p:spPr>
         <p:txBody>
-          <a:bodyPr xmlns:a="http://schemas.openxmlformats.org/drawingml/2006/main" anchor="ctr"/>
+          <a:bodyPr xmlns:a="http://schemas.openxmlformats.org/drawingml/2006/main" wrap="square" lIns="38100" tIns="19050" rIns="38100" bIns="19050" anchor="ctr">
+            <a:noAutofit/>
+          </a:bodyPr>
           <a:lstStyle xmlns:a="http://schemas.openxmlformats.org/drawingml/2006/main"/>
           <a:p xmlns:a="http://schemas.openxmlformats.org/drawingml/2006/main">
             <a:pPr algn="ctr">
@@ -1380,7 +1382,7 @@
           <p:cNvPr id="10" name="bar-2-1">
             <a:extLst xmlns:a="http://schemas.openxmlformats.org/drawingml/2006/main">
               <a:ext uri="{FF2B5EF4-FFF2-40B4-BE49-F238E27FC236}">
-                <a16:creationId xmlns:a16="http://schemas.microsoft.com/office/drawing/2014/main" id="{40B9E8E4-C6AE-43CD-98A0-BBDFEE8E6880}"/>
+                <a16:creationId xmlns:a16="http://schemas.microsoft.com/office/drawing/2014/main" id="{F18E023F-6E5E-46E6-A7C5-FF9FD2B4A096}"/>
               </a:ext>
             </a:extLst>
           </p:cNvPr>
@@ -1413,7 +1415,7 @@
           <p:cNvPr id="11" name="bar-label-2-1">
             <a:extLst xmlns:a="http://schemas.openxmlformats.org/drawingml/2006/main">
               <a:ext uri="{FF2B5EF4-FFF2-40B4-BE49-F238E27FC236}">
-                <a16:creationId xmlns:a16="http://schemas.microsoft.com/office/drawing/2014/main" id="{E3AAB5F7-61C1-4382-8797-7C1F23299333}"/>
+                <a16:creationId xmlns:a16="http://schemas.microsoft.com/office/drawing/2014/main" id="{67145317-B3FA-45E2-8D91-83AF37B8E943}"/>
               </a:ext>
             </a:extLst>
           </p:cNvPr>
@@ -1437,7 +1439,9 @@
           </a:ln>
         </p:spPr>
         <p:txBody>
-          <a:bodyPr xmlns:a="http://schemas.openxmlformats.org/drawingml/2006/main" anchor="ctr"/>
+          <a:bodyPr xmlns:a="http://schemas.openxmlformats.org/drawingml/2006/main" wrap="square" lIns="38100" tIns="19050" rIns="38100" bIns="19050" anchor="ctr">
+            <a:noAutofit/>
+          </a:bodyPr>
           <a:lstStyle xmlns:a="http://schemas.openxmlformats.org/drawingml/2006/main"/>
           <a:p xmlns:a="http://schemas.openxmlformats.org/drawingml/2006/main">
             <a:pPr algn="ctr">
@@ -1463,7 +1467,7 @@
           <p:cNvPr id="12" name="category-1">
             <a:extLst xmlns:a="http://schemas.openxmlformats.org/drawingml/2006/main">
               <a:ext uri="{FF2B5EF4-FFF2-40B4-BE49-F238E27FC236}">
-                <a16:creationId xmlns:a16="http://schemas.microsoft.com/office/drawing/2014/main" id="{F2CEE48A-42CC-4A01-8A40-FD1153091A59}"/>
+                <a16:creationId xmlns:a16="http://schemas.microsoft.com/office/drawing/2014/main" id="{A2B8EB0A-A34E-48C2-97BA-472CAA15E429}"/>
               </a:ext>
             </a:extLst>
           </p:cNvPr>
@@ -1487,7 +1491,9 @@
           </a:ln>
         </p:spPr>
         <p:txBody>
-          <a:bodyPr xmlns:a="http://schemas.openxmlformats.org/drawingml/2006/main" anchor="ctr"/>
+          <a:bodyPr xmlns:a="http://schemas.openxmlformats.org/drawingml/2006/main" wrap="square" lIns="38100" tIns="19050" rIns="38100" bIns="19050" anchor="ctr">
+            <a:noAutofit/>
+          </a:bodyPr>
           <a:lstStyle xmlns:a="http://schemas.openxmlformats.org/drawingml/2006/main"/>
           <a:p xmlns:a="http://schemas.openxmlformats.org/drawingml/2006/main">
             <a:pPr algn="ctr">
@@ -1513,7 +1519,7 @@
           <p:cNvPr id="13" name="bar-1-2">
             <a:extLst xmlns:a="http://schemas.openxmlformats.org/drawingml/2006/main">
               <a:ext uri="{FF2B5EF4-FFF2-40B4-BE49-F238E27FC236}">
-                <a16:creationId xmlns:a16="http://schemas.microsoft.com/office/drawing/2014/main" id="{DCBBA663-ADCB-4258-BB13-109ADADA40A9}"/>
+                <a16:creationId xmlns:a16="http://schemas.microsoft.com/office/drawing/2014/main" id="{A5789DCB-78A1-460E-9B75-1AAD2EE6C39D}"/>
               </a:ext>
             </a:extLst>
           </p:cNvPr>
@@ -1546,7 +1552,7 @@
           <p:cNvPr id="14" name="bar-label-1-2">
             <a:extLst xmlns:a="http://schemas.openxmlformats.org/drawingml/2006/main">
               <a:ext uri="{FF2B5EF4-FFF2-40B4-BE49-F238E27FC236}">
-                <a16:creationId xmlns:a16="http://schemas.microsoft.com/office/drawing/2014/main" id="{7A55E6AD-C538-403E-952F-C691FCEE76D3}"/>
+                <a16:creationId xmlns:a16="http://schemas.microsoft.com/office/drawing/2014/main" id="{78EF0D41-9606-4574-8A2A-5F2B7A08F21C}"/>
               </a:ext>
             </a:extLst>
           </p:cNvPr>
@@ -1570,7 +1576,9 @@
           </a:ln>
         </p:spPr>
         <p:txBody>
-          <a:bodyPr xmlns:a="http://schemas.openxmlformats.org/drawingml/2006/main" anchor="ctr"/>
+          <a:bodyPr xmlns:a="http://schemas.openxmlformats.org/drawingml/2006/main" wrap="square" lIns="38100" tIns="19050" rIns="38100" bIns="19050" anchor="ctr">
+            <a:noAutofit/>
+          </a:bodyPr>
           <a:lstStyle xmlns:a="http://schemas.openxmlformats.org/drawingml/2006/main"/>
           <a:p xmlns:a="http://schemas.openxmlformats.org/drawingml/2006/main">
             <a:pPr algn="ctr">
@@ -1596,7 +1604,7 @@
           <p:cNvPr id="15" name="bar-2-2">
             <a:extLst xmlns:a="http://schemas.openxmlformats.org/drawingml/2006/main">
               <a:ext uri="{FF2B5EF4-FFF2-40B4-BE49-F238E27FC236}">
-                <a16:creationId xmlns:a16="http://schemas.microsoft.com/office/drawing/2014/main" id="{2C238582-CAD9-4831-B476-62C6B8EA939F}"/>
+                <a16:creationId xmlns:a16="http://schemas.microsoft.com/office/drawing/2014/main" id="{DDA5E49F-BF2B-4306-8E5C-806CF36F8154}"/>
               </a:ext>
             </a:extLst>
           </p:cNvPr>
@@ -1629,7 +1637,7 @@
           <p:cNvPr id="16" name="bar-label-2-2">
             <a:extLst xmlns:a="http://schemas.openxmlformats.org/drawingml/2006/main">
               <a:ext uri="{FF2B5EF4-FFF2-40B4-BE49-F238E27FC236}">
-                <a16:creationId xmlns:a16="http://schemas.microsoft.com/office/drawing/2014/main" id="{D3B8B8AD-C423-4A7B-9C28-CFF12B117D54}"/>
+                <a16:creationId xmlns:a16="http://schemas.microsoft.com/office/drawing/2014/main" id="{56DF7E6F-9AE5-414D-ACE2-50AC31A2E4A4}"/>
               </a:ext>
             </a:extLst>
           </p:cNvPr>
@@ -1653,7 +1661,9 @@
           </a:ln>
         </p:spPr>
         <p:txBody>
-          <a:bodyPr xmlns:a="http://schemas.openxmlformats.org/drawingml/2006/main" anchor="ctr"/>
+          <a:bodyPr xmlns:a="http://schemas.openxmlformats.org/drawingml/2006/main" wrap="square" lIns="38100" tIns="19050" rIns="38100" bIns="19050" anchor="ctr">
+            <a:noAutofit/>
+          </a:bodyPr>
           <a:lstStyle xmlns:a="http://schemas.openxmlformats.org/drawingml/2006/main"/>
           <a:p xmlns:a="http://schemas.openxmlformats.org/drawingml/2006/main">
             <a:pPr algn="ctr">
@@ -1679,7 +1689,7 @@
           <p:cNvPr id="17" name="category-2">
             <a:extLst xmlns:a="http://schemas.openxmlformats.org/drawingml/2006/main">
               <a:ext uri="{FF2B5EF4-FFF2-40B4-BE49-F238E27FC236}">
-                <a16:creationId xmlns:a16="http://schemas.microsoft.com/office/drawing/2014/main" id="{51D796F2-D476-4E3D-B7C9-95EE990C7373}"/>
+                <a16:creationId xmlns:a16="http://schemas.microsoft.com/office/drawing/2014/main" id="{53C12DD5-EA8D-482F-A189-641FF43F86A1}"/>
               </a:ext>
             </a:extLst>
           </p:cNvPr>
@@ -1703,7 +1713,9 @@
           </a:ln>
         </p:spPr>
         <p:txBody>
-          <a:bodyPr xmlns:a="http://schemas.openxmlformats.org/drawingml/2006/main" anchor="ctr"/>
+          <a:bodyPr xmlns:a="http://schemas.openxmlformats.org/drawingml/2006/main" wrap="square" lIns="38100" tIns="19050" rIns="38100" bIns="19050" anchor="ctr">
+            <a:noAutofit/>
+          </a:bodyPr>
           <a:lstStyle xmlns:a="http://schemas.openxmlformats.org/drawingml/2006/main"/>
           <a:p xmlns:a="http://schemas.openxmlformats.org/drawingml/2006/main">
             <a:pPr algn="ctr">
@@ -1729,7 +1741,7 @@
           <p:cNvPr id="18" name="bar-1-3">
             <a:extLst xmlns:a="http://schemas.openxmlformats.org/drawingml/2006/main">
               <a:ext uri="{FF2B5EF4-FFF2-40B4-BE49-F238E27FC236}">
-                <a16:creationId xmlns:a16="http://schemas.microsoft.com/office/drawing/2014/main" id="{D887C363-4B29-45A8-AC0B-3C5C23D8E663}"/>
+                <a16:creationId xmlns:a16="http://schemas.microsoft.com/office/drawing/2014/main" id="{BD14C64F-F077-4F81-B78C-7929B6574690}"/>
               </a:ext>
             </a:extLst>
           </p:cNvPr>
@@ -1762,7 +1774,7 @@
           <p:cNvPr id="19" name="bar-label-1-3">
             <a:extLst xmlns:a="http://schemas.openxmlformats.org/drawingml/2006/main">
               <a:ext uri="{FF2B5EF4-FFF2-40B4-BE49-F238E27FC236}">
-                <a16:creationId xmlns:a16="http://schemas.microsoft.com/office/drawing/2014/main" id="{3B859DB4-DE9B-478B-8D07-611621367CDF}"/>
+                <a16:creationId xmlns:a16="http://schemas.microsoft.com/office/drawing/2014/main" id="{07B1DE3A-067A-407B-94A3-68BE3DB93DC8}"/>
               </a:ext>
             </a:extLst>
           </p:cNvPr>
@@ -1786,7 +1798,9 @@
           </a:ln>
         </p:spPr>
         <p:txBody>
-          <a:bodyPr xmlns:a="http://schemas.openxmlformats.org/drawingml/2006/main" anchor="ctr"/>
+          <a:bodyPr xmlns:a="http://schemas.openxmlformats.org/drawingml/2006/main" wrap="square" lIns="38100" tIns="19050" rIns="38100" bIns="19050" anchor="ctr">
+            <a:noAutofit/>
+          </a:bodyPr>
           <a:lstStyle xmlns:a="http://schemas.openxmlformats.org/drawingml/2006/main"/>
           <a:p xmlns:a="http://schemas.openxmlformats.org/drawingml/2006/main">
             <a:pPr algn="ctr">
@@ -1812,7 +1826,7 @@
           <p:cNvPr id="20" name="bar-2-3">
             <a:extLst xmlns:a="http://schemas.openxmlformats.org/drawingml/2006/main">
               <a:ext uri="{FF2B5EF4-FFF2-40B4-BE49-F238E27FC236}">
-                <a16:creationId xmlns:a16="http://schemas.microsoft.com/office/drawing/2014/main" id="{A2140C8D-8D9B-4FA9-8B30-D77147CEC6E2}"/>
+                <a16:creationId xmlns:a16="http://schemas.microsoft.com/office/drawing/2014/main" id="{B234E7E8-4B07-4611-B9DC-FC3ED9FF93CB}"/>
               </a:ext>
             </a:extLst>
           </p:cNvPr>
@@ -1845,7 +1859,7 @@
           <p:cNvPr id="21" name="bar-label-2-3">
             <a:extLst xmlns:a="http://schemas.openxmlformats.org/drawingml/2006/main">
               <a:ext uri="{FF2B5EF4-FFF2-40B4-BE49-F238E27FC236}">
-                <a16:creationId xmlns:a16="http://schemas.microsoft.com/office/drawing/2014/main" id="{1A74C84D-C362-478E-8FE3-F97EBCA66E54}"/>
+                <a16:creationId xmlns:a16="http://schemas.microsoft.com/office/drawing/2014/main" id="{1E130A4E-02A4-492A-B924-BD7666D5D66E}"/>
               </a:ext>
             </a:extLst>
           </p:cNvPr>
@@ -1869,7 +1883,9 @@
           </a:ln>
         </p:spPr>
         <p:txBody>
-          <a:bodyPr xmlns:a="http://schemas.openxmlformats.org/drawingml/2006/main" anchor="ctr"/>
+          <a:bodyPr xmlns:a="http://schemas.openxmlformats.org/drawingml/2006/main" wrap="square" lIns="38100" tIns="19050" rIns="38100" bIns="19050" anchor="ctr">
+            <a:noAutofit/>
+          </a:bodyPr>
           <a:lstStyle xmlns:a="http://schemas.openxmlformats.org/drawingml/2006/main"/>
           <a:p xmlns:a="http://schemas.openxmlformats.org/drawingml/2006/main">
             <a:pPr algn="ctr">
@@ -1895,7 +1911,7 @@
           <p:cNvPr id="22" name="category-3">
             <a:extLst xmlns:a="http://schemas.openxmlformats.org/drawingml/2006/main">
               <a:ext uri="{FF2B5EF4-FFF2-40B4-BE49-F238E27FC236}">
-                <a16:creationId xmlns:a16="http://schemas.microsoft.com/office/drawing/2014/main" id="{1946DFA2-CB66-4013-A937-6666827FB10C}"/>
+                <a16:creationId xmlns:a16="http://schemas.microsoft.com/office/drawing/2014/main" id="{060EDA0C-B567-48DC-9DD9-53C2EBB60594}"/>
               </a:ext>
             </a:extLst>
           </p:cNvPr>
@@ -1919,7 +1935,9 @@
           </a:ln>
         </p:spPr>
         <p:txBody>
-          <a:bodyPr xmlns:a="http://schemas.openxmlformats.org/drawingml/2006/main" anchor="ctr"/>
+          <a:bodyPr xmlns:a="http://schemas.openxmlformats.org/drawingml/2006/main" wrap="square" lIns="38100" tIns="19050" rIns="38100" bIns="19050" anchor="ctr">
+            <a:noAutofit/>
+          </a:bodyPr>
           <a:lstStyle xmlns:a="http://schemas.openxmlformats.org/drawingml/2006/main"/>
           <a:p xmlns:a="http://schemas.openxmlformats.org/drawingml/2006/main">
             <a:pPr algn="ctr">
@@ -1945,7 +1963,7 @@
           <p:cNvPr id="23" name="bar-1-4">
             <a:extLst xmlns:a="http://schemas.openxmlformats.org/drawingml/2006/main">
               <a:ext uri="{FF2B5EF4-FFF2-40B4-BE49-F238E27FC236}">
-                <a16:creationId xmlns:a16="http://schemas.microsoft.com/office/drawing/2014/main" id="{8ADD778A-776C-4A63-83A9-9A68E92718CE}"/>
+                <a16:creationId xmlns:a16="http://schemas.microsoft.com/office/drawing/2014/main" id="{71DCDFC7-C986-4C9A-82EB-0732C333C310}"/>
               </a:ext>
             </a:extLst>
           </p:cNvPr>
@@ -1978,7 +1996,7 @@
           <p:cNvPr id="24" name="bar-label-1-4">
             <a:extLst xmlns:a="http://schemas.openxmlformats.org/drawingml/2006/main">
               <a:ext uri="{FF2B5EF4-FFF2-40B4-BE49-F238E27FC236}">
-                <a16:creationId xmlns:a16="http://schemas.microsoft.com/office/drawing/2014/main" id="{7D71E6CD-D7EC-4F0F-91C3-5EF7024E6C46}"/>
+                <a16:creationId xmlns:a16="http://schemas.microsoft.com/office/drawing/2014/main" id="{C1FA03D3-E5FF-484C-A226-80E01667B19B}"/>
               </a:ext>
             </a:extLst>
           </p:cNvPr>
@@ -2002,7 +2020,9 @@
           </a:ln>
         </p:spPr>
         <p:txBody>
-          <a:bodyPr xmlns:a="http://schemas.openxmlformats.org/drawingml/2006/main" anchor="ctr"/>
+          <a:bodyPr xmlns:a="http://schemas.openxmlformats.org/drawingml/2006/main" wrap="square" lIns="38100" tIns="19050" rIns="38100" bIns="19050" anchor="ctr">
+            <a:noAutofit/>
+          </a:bodyPr>
           <a:lstStyle xmlns:a="http://schemas.openxmlformats.org/drawingml/2006/main"/>
           <a:p xmlns:a="http://schemas.openxmlformats.org/drawingml/2006/main">
             <a:pPr algn="ctr">
@@ -2028,7 +2048,7 @@
           <p:cNvPr id="25" name="bar-2-4">
             <a:extLst xmlns:a="http://schemas.openxmlformats.org/drawingml/2006/main">
               <a:ext uri="{FF2B5EF4-FFF2-40B4-BE49-F238E27FC236}">
-                <a16:creationId xmlns:a16="http://schemas.microsoft.com/office/drawing/2014/main" id="{CCA8AAE1-7699-4CA8-800F-33BC8BEE8EB7}"/>
+                <a16:creationId xmlns:a16="http://schemas.microsoft.com/office/drawing/2014/main" id="{39E973CE-7A52-4C81-B372-9F622B5A28FE}"/>
               </a:ext>
             </a:extLst>
           </p:cNvPr>
@@ -2061,7 +2081,7 @@
           <p:cNvPr id="26" name="bar-label-2-4">
             <a:extLst xmlns:a="http://schemas.openxmlformats.org/drawingml/2006/main">
               <a:ext uri="{FF2B5EF4-FFF2-40B4-BE49-F238E27FC236}">
-                <a16:creationId xmlns:a16="http://schemas.microsoft.com/office/drawing/2014/main" id="{AE582784-1D31-4B77-A220-4AA6EE91A189}"/>
+                <a16:creationId xmlns:a16="http://schemas.microsoft.com/office/drawing/2014/main" id="{C7441945-1B63-436F-9A01-3BA612058C6A}"/>
               </a:ext>
             </a:extLst>
           </p:cNvPr>
@@ -2085,7 +2105,9 @@
           </a:ln>
         </p:spPr>
         <p:txBody>
-          <a:bodyPr xmlns:a="http://schemas.openxmlformats.org/drawingml/2006/main" anchor="ctr"/>
+          <a:bodyPr xmlns:a="http://schemas.openxmlformats.org/drawingml/2006/main" wrap="square" lIns="38100" tIns="19050" rIns="38100" bIns="19050" anchor="ctr">
+            <a:noAutofit/>
+          </a:bodyPr>
           <a:lstStyle xmlns:a="http://schemas.openxmlformats.org/drawingml/2006/main"/>
           <a:p xmlns:a="http://schemas.openxmlformats.org/drawingml/2006/main">
             <a:pPr algn="ctr">
@@ -2111,7 +2133,7 @@
           <p:cNvPr id="27" name="category-4">
             <a:extLst xmlns:a="http://schemas.openxmlformats.org/drawingml/2006/main">
               <a:ext uri="{FF2B5EF4-FFF2-40B4-BE49-F238E27FC236}">
-                <a16:creationId xmlns:a16="http://schemas.microsoft.com/office/drawing/2014/main" id="{781F0EF7-FD83-4576-BE0E-70C3866983B5}"/>
+                <a16:creationId xmlns:a16="http://schemas.microsoft.com/office/drawing/2014/main" id="{44BBA7A4-0AD3-4D81-AEFC-5918082D29A5}"/>
               </a:ext>
             </a:extLst>
           </p:cNvPr>
@@ -2135,7 +2157,9 @@
           </a:ln>
         </p:spPr>
         <p:txBody>
-          <a:bodyPr xmlns:a="http://schemas.openxmlformats.org/drawingml/2006/main" anchor="ctr"/>
+          <a:bodyPr xmlns:a="http://schemas.openxmlformats.org/drawingml/2006/main" wrap="square" lIns="38100" tIns="19050" rIns="38100" bIns="19050" anchor="ctr">
+            <a:noAutofit/>
+          </a:bodyPr>
           <a:lstStyle xmlns:a="http://schemas.openxmlformats.org/drawingml/2006/main"/>
           <a:p xmlns:a="http://schemas.openxmlformats.org/drawingml/2006/main">
             <a:pPr algn="ctr">
@@ -2161,7 +2185,7 @@
           <p:cNvPr id="28" name="bar-1-5">
             <a:extLst xmlns:a="http://schemas.openxmlformats.org/drawingml/2006/main">
               <a:ext uri="{FF2B5EF4-FFF2-40B4-BE49-F238E27FC236}">
-                <a16:creationId xmlns:a16="http://schemas.microsoft.com/office/drawing/2014/main" id="{1E7FA8F2-8F4E-4042-B0AF-AED5D01E1A64}"/>
+                <a16:creationId xmlns:a16="http://schemas.microsoft.com/office/drawing/2014/main" id="{24775FE7-AE75-4CC6-A3B0-F2B503815558}"/>
               </a:ext>
             </a:extLst>
           </p:cNvPr>
@@ -2194,7 +2218,7 @@
           <p:cNvPr id="29" name="bar-label-1-5">
             <a:extLst xmlns:a="http://schemas.openxmlformats.org/drawingml/2006/main">
               <a:ext uri="{FF2B5EF4-FFF2-40B4-BE49-F238E27FC236}">
-                <a16:creationId xmlns:a16="http://schemas.microsoft.com/office/drawing/2014/main" id="{EB4EE9AE-D5A9-4B6D-9D14-770D5A2943D9}"/>
+                <a16:creationId xmlns:a16="http://schemas.microsoft.com/office/drawing/2014/main" id="{CF0A415E-982A-4281-96BE-2C772A5A843B}"/>
               </a:ext>
             </a:extLst>
           </p:cNvPr>
@@ -2218,7 +2242,9 @@
           </a:ln>
         </p:spPr>
         <p:txBody>
-          <a:bodyPr xmlns:a="http://schemas.openxmlformats.org/drawingml/2006/main" anchor="ctr"/>
+          <a:bodyPr xmlns:a="http://schemas.openxmlformats.org/drawingml/2006/main" wrap="square" lIns="38100" tIns="19050" rIns="38100" bIns="19050" anchor="ctr">
+            <a:noAutofit/>
+          </a:bodyPr>
           <a:lstStyle xmlns:a="http://schemas.openxmlformats.org/drawingml/2006/main"/>
           <a:p xmlns:a="http://schemas.openxmlformats.org/drawingml/2006/main">
             <a:pPr algn="ctr">
@@ -2244,7 +2270,7 @@
           <p:cNvPr id="30" name="bar-2-5">
             <a:extLst xmlns:a="http://schemas.openxmlformats.org/drawingml/2006/main">
               <a:ext uri="{FF2B5EF4-FFF2-40B4-BE49-F238E27FC236}">
-                <a16:creationId xmlns:a16="http://schemas.microsoft.com/office/drawing/2014/main" id="{F917C143-C8C1-4D51-9417-F1E8097DB1A3}"/>
+                <a16:creationId xmlns:a16="http://schemas.microsoft.com/office/drawing/2014/main" id="{33712C91-C00D-4DD0-BF0F-A03095889667}"/>
               </a:ext>
             </a:extLst>
           </p:cNvPr>
@@ -2277,7 +2303,7 @@
           <p:cNvPr id="31" name="bar-label-2-5">
             <a:extLst xmlns:a="http://schemas.openxmlformats.org/drawingml/2006/main">
               <a:ext uri="{FF2B5EF4-FFF2-40B4-BE49-F238E27FC236}">
-                <a16:creationId xmlns:a16="http://schemas.microsoft.com/office/drawing/2014/main" id="{C0BB0420-FD8E-46FF-8600-F4931E46D7B0}"/>
+                <a16:creationId xmlns:a16="http://schemas.microsoft.com/office/drawing/2014/main" id="{9F0967D0-5895-4372-9022-8F94C93D5A74}"/>
               </a:ext>
             </a:extLst>
           </p:cNvPr>
@@ -2301,7 +2327,9 @@
           </a:ln>
         </p:spPr>
         <p:txBody>
-          <a:bodyPr xmlns:a="http://schemas.openxmlformats.org/drawingml/2006/main" anchor="ctr"/>
+          <a:bodyPr xmlns:a="http://schemas.openxmlformats.org/drawingml/2006/main" wrap="square" lIns="38100" tIns="19050" rIns="38100" bIns="19050" anchor="ctr">
+            <a:noAutofit/>
+          </a:bodyPr>
           <a:lstStyle xmlns:a="http://schemas.openxmlformats.org/drawingml/2006/main"/>
           <a:p xmlns:a="http://schemas.openxmlformats.org/drawingml/2006/main">
             <a:pPr algn="ctr">
@@ -2327,7 +2355,7 @@
           <p:cNvPr id="32" name="category-5">
             <a:extLst xmlns:a="http://schemas.openxmlformats.org/drawingml/2006/main">
               <a:ext uri="{FF2B5EF4-FFF2-40B4-BE49-F238E27FC236}">
-                <a16:creationId xmlns:a16="http://schemas.microsoft.com/office/drawing/2014/main" id="{7881B0CF-D1A7-4A21-9C6B-82DCDD594CE7}"/>
+                <a16:creationId xmlns:a16="http://schemas.microsoft.com/office/drawing/2014/main" id="{2AF4BA63-C2A2-44F6-9B50-7927C8F1035A}"/>
               </a:ext>
             </a:extLst>
           </p:cNvPr>
@@ -2351,7 +2379,9 @@
           </a:ln>
         </p:spPr>
         <p:txBody>
-          <a:bodyPr xmlns:a="http://schemas.openxmlformats.org/drawingml/2006/main" anchor="ctr"/>
+          <a:bodyPr xmlns:a="http://schemas.openxmlformats.org/drawingml/2006/main" wrap="square" lIns="38100" tIns="19050" rIns="38100" bIns="19050" anchor="ctr">
+            <a:noAutofit/>
+          </a:bodyPr>
           <a:lstStyle xmlns:a="http://schemas.openxmlformats.org/drawingml/2006/main"/>
           <a:p xmlns:a="http://schemas.openxmlformats.org/drawingml/2006/main">
             <a:pPr algn="ctr">
@@ -2377,7 +2407,7 @@
           <p:cNvPr id="33" name="bar-1-6">
             <a:extLst xmlns:a="http://schemas.openxmlformats.org/drawingml/2006/main">
               <a:ext uri="{FF2B5EF4-FFF2-40B4-BE49-F238E27FC236}">
-                <a16:creationId xmlns:a16="http://schemas.microsoft.com/office/drawing/2014/main" id="{966FD036-E79F-4C0F-8861-22F3EE1CA19A}"/>
+                <a16:creationId xmlns:a16="http://schemas.microsoft.com/office/drawing/2014/main" id="{E4585289-5161-4D10-8B75-E79B438798D2}"/>
               </a:ext>
             </a:extLst>
           </p:cNvPr>
@@ -2410,7 +2440,7 @@
           <p:cNvPr id="34" name="bar-label-1-6">
             <a:extLst xmlns:a="http://schemas.openxmlformats.org/drawingml/2006/main">
               <a:ext uri="{FF2B5EF4-FFF2-40B4-BE49-F238E27FC236}">
-                <a16:creationId xmlns:a16="http://schemas.microsoft.com/office/drawing/2014/main" id="{F5674D12-B1F1-431A-847C-7290B8E20361}"/>
+                <a16:creationId xmlns:a16="http://schemas.microsoft.com/office/drawing/2014/main" id="{BEA45BB3-4D27-4F27-95D8-FE8307ACB353}"/>
               </a:ext>
             </a:extLst>
           </p:cNvPr>
@@ -2434,7 +2464,9 @@
           </a:ln>
         </p:spPr>
         <p:txBody>
-          <a:bodyPr xmlns:a="http://schemas.openxmlformats.org/drawingml/2006/main" anchor="ctr"/>
+          <a:bodyPr xmlns:a="http://schemas.openxmlformats.org/drawingml/2006/main" wrap="square" lIns="38100" tIns="19050" rIns="38100" bIns="19050" anchor="ctr">
+            <a:noAutofit/>
+          </a:bodyPr>
           <a:lstStyle xmlns:a="http://schemas.openxmlformats.org/drawingml/2006/main"/>
           <a:p xmlns:a="http://schemas.openxmlformats.org/drawingml/2006/main">
             <a:pPr algn="ctr">
@@ -2460,7 +2492,7 @@
           <p:cNvPr id="35" name="bar-2-6">
             <a:extLst xmlns:a="http://schemas.openxmlformats.org/drawingml/2006/main">
               <a:ext uri="{FF2B5EF4-FFF2-40B4-BE49-F238E27FC236}">
-                <a16:creationId xmlns:a16="http://schemas.microsoft.com/office/drawing/2014/main" id="{EBBB1D2F-8981-4864-9168-C5FB9743F337}"/>
+                <a16:creationId xmlns:a16="http://schemas.microsoft.com/office/drawing/2014/main" id="{BAE1F49D-BFBE-4BDD-94B2-70527FBAF839}"/>
               </a:ext>
             </a:extLst>
           </p:cNvPr>
@@ -2493,7 +2525,7 @@
           <p:cNvPr id="36" name="bar-label-2-6">
             <a:extLst xmlns:a="http://schemas.openxmlformats.org/drawingml/2006/main">
               <a:ext uri="{FF2B5EF4-FFF2-40B4-BE49-F238E27FC236}">
-                <a16:creationId xmlns:a16="http://schemas.microsoft.com/office/drawing/2014/main" id="{B583107C-9BBB-4F70-ADAE-D56082C998F6}"/>
+                <a16:creationId xmlns:a16="http://schemas.microsoft.com/office/drawing/2014/main" id="{681F9875-8AD7-49BD-ABDC-FC313B9B1B37}"/>
               </a:ext>
             </a:extLst>
           </p:cNvPr>
@@ -2517,7 +2549,9 @@
           </a:ln>
         </p:spPr>
         <p:txBody>
-          <a:bodyPr xmlns:a="http://schemas.openxmlformats.org/drawingml/2006/main" anchor="ctr"/>
+          <a:bodyPr xmlns:a="http://schemas.openxmlformats.org/drawingml/2006/main" wrap="square" lIns="38100" tIns="19050" rIns="38100" bIns="19050" anchor="ctr">
+            <a:noAutofit/>
+          </a:bodyPr>
           <a:lstStyle xmlns:a="http://schemas.openxmlformats.org/drawingml/2006/main"/>
           <a:p xmlns:a="http://schemas.openxmlformats.org/drawingml/2006/main">
             <a:pPr algn="ctr">
@@ -2543,7 +2577,7 @@
           <p:cNvPr id="37" name="category-6">
             <a:extLst xmlns:a="http://schemas.openxmlformats.org/drawingml/2006/main">
               <a:ext uri="{FF2B5EF4-FFF2-40B4-BE49-F238E27FC236}">
-                <a16:creationId xmlns:a16="http://schemas.microsoft.com/office/drawing/2014/main" id="{F527A069-5129-4419-AA1A-4BA21A893944}"/>
+                <a16:creationId xmlns:a16="http://schemas.microsoft.com/office/drawing/2014/main" id="{D44B86DB-F9CF-4CD9-A1AB-6C5F82B3AB96}"/>
               </a:ext>
             </a:extLst>
           </p:cNvPr>
@@ -2567,7 +2601,9 @@
           </a:ln>
         </p:spPr>
         <p:txBody>
-          <a:bodyPr xmlns:a="http://schemas.openxmlformats.org/drawingml/2006/main" anchor="ctr"/>
+          <a:bodyPr xmlns:a="http://schemas.openxmlformats.org/drawingml/2006/main" wrap="square" lIns="38100" tIns="19050" rIns="38100" bIns="19050" anchor="ctr">
+            <a:noAutofit/>
+          </a:bodyPr>
           <a:lstStyle xmlns:a="http://schemas.openxmlformats.org/drawingml/2006/main"/>
           <a:p xmlns:a="http://schemas.openxmlformats.org/drawingml/2006/main">
             <a:pPr algn="ctr">
@@ -2593,19 +2629,19 @@
           <p:cNvPr id="38" name="ratio-line-1">
             <a:extLst xmlns:a="http://schemas.openxmlformats.org/drawingml/2006/main">
               <a:ext uri="{FF2B5EF4-FFF2-40B4-BE49-F238E27FC236}">
-                <a16:creationId xmlns:a16="http://schemas.microsoft.com/office/drawing/2014/main" id="{42A9E1FA-DB60-433A-8080-5A92503B0325}"/>
-              </a:ext>
-            </a:extLst>
-          </p:cNvPr>
-          <p:cNvSpPr>
-            <a:spLocks xmlns:a="http://schemas.openxmlformats.org/drawingml/2006/main" noGrp="1"/>
-          </p:cNvSpPr>
-          <p:nvPr/>
-        </p:nvSpPr>
-        <p:spPr>
-          <a:xfrm xmlns:a="http://schemas.openxmlformats.org/drawingml/2006/main">
-            <a:off x="1677988" y="2095500"/>
-            <a:ext cx="1069975" cy="511969"/>
+                <a16:creationId xmlns:a16="http://schemas.microsoft.com/office/drawing/2014/main" id="{A898C2D4-0C25-41C3-8270-F7E4637B0687}"/>
+              </a:ext>
+            </a:extLst>
+          </p:cNvPr>
+          <p:cNvSpPr>
+            <a:spLocks xmlns:a="http://schemas.openxmlformats.org/drawingml/2006/main" noGrp="1"/>
+          </p:cNvSpPr>
+          <p:nvPr/>
+        </p:nvSpPr>
+        <p:spPr>
+          <a:xfrm xmlns:a="http://schemas.openxmlformats.org/drawingml/2006/main">
+            <a:off x="1677988" y="2446564"/>
+            <a:ext cx="1069975" cy="351064"/>
           </a:xfrm>
           <a:prstGeom xmlns:a="http://schemas.openxmlformats.org/drawingml/2006/main" prst="line">
             <a:avLst/>
@@ -2624,19 +2660,19 @@
           <p:cNvPr id="39" name="ratio-line-2">
             <a:extLst xmlns:a="http://schemas.openxmlformats.org/drawingml/2006/main">
               <a:ext uri="{FF2B5EF4-FFF2-40B4-BE49-F238E27FC236}">
-                <a16:creationId xmlns:a16="http://schemas.microsoft.com/office/drawing/2014/main" id="{19609D5A-9EA8-4328-B20B-A0EE8373B226}"/>
-              </a:ext>
-            </a:extLst>
-          </p:cNvPr>
-          <p:cNvSpPr>
-            <a:spLocks xmlns:a="http://schemas.openxmlformats.org/drawingml/2006/main" noGrp="1"/>
-          </p:cNvSpPr>
-          <p:nvPr/>
-        </p:nvSpPr>
-        <p:spPr>
-          <a:xfrm xmlns:a="http://schemas.openxmlformats.org/drawingml/2006/main">
-            <a:off x="2747963" y="2607469"/>
-            <a:ext cx="1069975" cy="716756"/>
+                <a16:creationId xmlns:a16="http://schemas.microsoft.com/office/drawing/2014/main" id="{379FAA82-3D67-4CE1-95DE-0990341252EB}"/>
+              </a:ext>
+            </a:extLst>
+          </p:cNvPr>
+          <p:cNvSpPr>
+            <a:spLocks xmlns:a="http://schemas.openxmlformats.org/drawingml/2006/main" noGrp="1"/>
+          </p:cNvSpPr>
+          <p:nvPr/>
+        </p:nvSpPr>
+        <p:spPr>
+          <a:xfrm xmlns:a="http://schemas.openxmlformats.org/drawingml/2006/main">
+            <a:off x="2747963" y="2797629"/>
+            <a:ext cx="1069975" cy="491490"/>
           </a:xfrm>
           <a:prstGeom xmlns:a="http://schemas.openxmlformats.org/drawingml/2006/main" prst="line">
             <a:avLst/>
@@ -2655,19 +2691,19 @@
           <p:cNvPr id="40" name="ratio-line-3">
             <a:extLst xmlns:a="http://schemas.openxmlformats.org/drawingml/2006/main">
               <a:ext uri="{FF2B5EF4-FFF2-40B4-BE49-F238E27FC236}">
-                <a16:creationId xmlns:a16="http://schemas.microsoft.com/office/drawing/2014/main" id="{4D559376-806B-47D6-B44B-C389038F279D}"/>
-              </a:ext>
-            </a:extLst>
-          </p:cNvPr>
-          <p:cNvSpPr>
-            <a:spLocks xmlns:a="http://schemas.openxmlformats.org/drawingml/2006/main" noGrp="1"/>
-          </p:cNvSpPr>
-          <p:nvPr/>
-        </p:nvSpPr>
-        <p:spPr>
-          <a:xfrm xmlns:a="http://schemas.openxmlformats.org/drawingml/2006/main">
-            <a:off x="3817938" y="3324225"/>
-            <a:ext cx="1069975" cy="511969"/>
+                <a16:creationId xmlns:a16="http://schemas.microsoft.com/office/drawing/2014/main" id="{A17774EC-3ACC-46C5-B5C3-3DA3CB30E94E}"/>
+              </a:ext>
+            </a:extLst>
+          </p:cNvPr>
+          <p:cNvSpPr>
+            <a:spLocks xmlns:a="http://schemas.openxmlformats.org/drawingml/2006/main" noGrp="1"/>
+          </p:cNvSpPr>
+          <p:nvPr/>
+        </p:nvSpPr>
+        <p:spPr>
+          <a:xfrm xmlns:a="http://schemas.openxmlformats.org/drawingml/2006/main">
+            <a:off x="3817938" y="3289119"/>
+            <a:ext cx="1069975" cy="351064"/>
           </a:xfrm>
           <a:prstGeom xmlns:a="http://schemas.openxmlformats.org/drawingml/2006/main" prst="line">
             <a:avLst/>
@@ -2686,19 +2722,19 @@
           <p:cNvPr id="41" name="ratio-line-4">
             <a:extLst xmlns:a="http://schemas.openxmlformats.org/drawingml/2006/main">
               <a:ext uri="{FF2B5EF4-FFF2-40B4-BE49-F238E27FC236}">
-                <a16:creationId xmlns:a16="http://schemas.microsoft.com/office/drawing/2014/main" id="{564D7EFB-C41B-498D-8896-571A22E5F5AE}"/>
-              </a:ext>
-            </a:extLst>
-          </p:cNvPr>
-          <p:cNvSpPr>
-            <a:spLocks xmlns:a="http://schemas.openxmlformats.org/drawingml/2006/main" noGrp="1"/>
-          </p:cNvSpPr>
-          <p:nvPr/>
-        </p:nvSpPr>
-        <p:spPr>
-          <a:xfrm xmlns:a="http://schemas.openxmlformats.org/drawingml/2006/main">
-            <a:off x="4887913" y="3836194"/>
-            <a:ext cx="1069975" cy="409575"/>
+                <a16:creationId xmlns:a16="http://schemas.microsoft.com/office/drawing/2014/main" id="{ECBEAD7E-6829-4916-9290-7B537FF8119D}"/>
+              </a:ext>
+            </a:extLst>
+          </p:cNvPr>
+          <p:cNvSpPr>
+            <a:spLocks xmlns:a="http://schemas.openxmlformats.org/drawingml/2006/main" noGrp="1"/>
+          </p:cNvSpPr>
+          <p:nvPr/>
+        </p:nvSpPr>
+        <p:spPr>
+          <a:xfrm xmlns:a="http://schemas.openxmlformats.org/drawingml/2006/main">
+            <a:off x="4887913" y="3640183"/>
+            <a:ext cx="1069975" cy="280851"/>
           </a:xfrm>
           <a:prstGeom xmlns:a="http://schemas.openxmlformats.org/drawingml/2006/main" prst="line">
             <a:avLst/>
@@ -2717,19 +2753,19 @@
           <p:cNvPr id="42" name="ratio-line-5">
             <a:extLst xmlns:a="http://schemas.openxmlformats.org/drawingml/2006/main">
               <a:ext uri="{FF2B5EF4-FFF2-40B4-BE49-F238E27FC236}">
-                <a16:creationId xmlns:a16="http://schemas.microsoft.com/office/drawing/2014/main" id="{55762550-8FFD-46BE-9026-2843C3DFF2E4}"/>
-              </a:ext>
-            </a:extLst>
-          </p:cNvPr>
-          <p:cNvSpPr>
-            <a:spLocks xmlns:a="http://schemas.openxmlformats.org/drawingml/2006/main" noGrp="1"/>
-          </p:cNvSpPr>
-          <p:nvPr/>
-        </p:nvSpPr>
-        <p:spPr>
-          <a:xfrm xmlns:a="http://schemas.openxmlformats.org/drawingml/2006/main">
-            <a:off x="5957888" y="4245769"/>
-            <a:ext cx="1069975" cy="307181"/>
+                <a16:creationId xmlns:a16="http://schemas.microsoft.com/office/drawing/2014/main" id="{58DC0B83-D47F-46F7-8022-25BEE55029E0}"/>
+              </a:ext>
+            </a:extLst>
+          </p:cNvPr>
+          <p:cNvSpPr>
+            <a:spLocks xmlns:a="http://schemas.openxmlformats.org/drawingml/2006/main" noGrp="1"/>
+          </p:cNvSpPr>
+          <p:nvPr/>
+        </p:nvSpPr>
+        <p:spPr>
+          <a:xfrm xmlns:a="http://schemas.openxmlformats.org/drawingml/2006/main">
+            <a:off x="5957888" y="3921034"/>
+            <a:ext cx="1069975" cy="210639"/>
           </a:xfrm>
           <a:prstGeom xmlns:a="http://schemas.openxmlformats.org/drawingml/2006/main" prst="line">
             <a:avLst/>
@@ -2748,18 +2784,18 @@
           <p:cNvPr id="43" name="ratio-point-1">
             <a:extLst xmlns:a="http://schemas.openxmlformats.org/drawingml/2006/main">
               <a:ext uri="{FF2B5EF4-FFF2-40B4-BE49-F238E27FC236}">
-                <a16:creationId xmlns:a16="http://schemas.microsoft.com/office/drawing/2014/main" id="{20CBB638-FF23-46AF-A99F-91B74A772C0D}"/>
-              </a:ext>
-            </a:extLst>
-          </p:cNvPr>
-          <p:cNvSpPr>
-            <a:spLocks xmlns:a="http://schemas.openxmlformats.org/drawingml/2006/main" noGrp="1"/>
-          </p:cNvSpPr>
-          <p:nvPr/>
-        </p:nvSpPr>
-        <p:spPr>
-          <a:xfrm xmlns:a="http://schemas.openxmlformats.org/drawingml/2006/main">
-            <a:off x="1630363" y="2047875"/>
+                <a16:creationId xmlns:a16="http://schemas.microsoft.com/office/drawing/2014/main" id="{F1E315F5-A2C2-4272-B288-D041B2DB6542}"/>
+              </a:ext>
+            </a:extLst>
+          </p:cNvPr>
+          <p:cNvSpPr>
+            <a:spLocks xmlns:a="http://schemas.openxmlformats.org/drawingml/2006/main" noGrp="1"/>
+          </p:cNvSpPr>
+          <p:nvPr/>
+        </p:nvSpPr>
+        <p:spPr>
+          <a:xfrm xmlns:a="http://schemas.openxmlformats.org/drawingml/2006/main">
+            <a:off x="1630363" y="2398939"/>
             <a:ext cx="95250" cy="95250"/>
           </a:xfrm>
           <a:prstGeom xmlns:a="http://schemas.openxmlformats.org/drawingml/2006/main" prst="ellipse">
@@ -2776,7 +2812,9 @@
           </a:ln>
         </p:spPr>
         <p:txBody>
-          <a:bodyPr xmlns:a="http://schemas.openxmlformats.org/drawingml/2006/main" anchor="ctr"/>
+          <a:bodyPr xmlns:a="http://schemas.openxmlformats.org/drawingml/2006/main" wrap="square" lIns="38100" tIns="19050" rIns="38100" bIns="19050" anchor="ctr">
+            <a:noAutofit/>
+          </a:bodyPr>
           <a:lstStyle xmlns:a="http://schemas.openxmlformats.org/drawingml/2006/main"/>
           <a:p xmlns:a="http://schemas.openxmlformats.org/drawingml/2006/main">
             <a:r>
@@ -2787,21 +2825,73 @@
       </p:sp>
       <p:sp>
         <p:nvSpPr>
-          <p:cNvPr id="44" name="ratio-point-2">
-            <a:extLst xmlns:a="http://schemas.openxmlformats.org/drawingml/2006/main">
-              <a:ext uri="{FF2B5EF4-FFF2-40B4-BE49-F238E27FC236}">
-                <a16:creationId xmlns:a16="http://schemas.microsoft.com/office/drawing/2014/main" id="{E5ED404A-489B-4CC9-9204-39F4284B1AAB}"/>
-              </a:ext>
-            </a:extLst>
-          </p:cNvPr>
-          <p:cNvSpPr>
-            <a:spLocks xmlns:a="http://schemas.openxmlformats.org/drawingml/2006/main" noGrp="1"/>
-          </p:cNvSpPr>
-          <p:nvPr/>
-        </p:nvSpPr>
-        <p:spPr>
-          <a:xfrm xmlns:a="http://schemas.openxmlformats.org/drawingml/2006/main">
-            <a:off x="2700338" y="2559844"/>
+          <p:cNvPr id="44" name="ratio-label-1">
+            <a:extLst xmlns:a="http://schemas.openxmlformats.org/drawingml/2006/main">
+              <a:ext uri="{FF2B5EF4-FFF2-40B4-BE49-F238E27FC236}">
+                <a16:creationId xmlns:a16="http://schemas.microsoft.com/office/drawing/2014/main" id="{982AC7C6-3943-44FF-927A-D9931DE94E27}"/>
+              </a:ext>
+            </a:extLst>
+          </p:cNvPr>
+          <p:cNvSpPr>
+            <a:spLocks xmlns:a="http://schemas.openxmlformats.org/drawingml/2006/main" noGrp="1"/>
+          </p:cNvSpPr>
+          <p:nvPr/>
+        </p:nvSpPr>
+        <p:spPr>
+          <a:xfrm xmlns:a="http://schemas.openxmlformats.org/drawingml/2006/main">
+            <a:off x="1354138" y="2189389"/>
+            <a:ext cx="647700" cy="209550"/>
+          </a:xfrm>
+          <a:prstGeom xmlns:a="http://schemas.openxmlformats.org/drawingml/2006/main" prst="rect">
+            <a:avLst/>
+          </a:prstGeom>
+          <a:noFill xmlns:a="http://schemas.openxmlformats.org/drawingml/2006/main"/>
+          <a:ln xmlns:a="http://schemas.openxmlformats.org/drawingml/2006/main" w="0">
+            <a:noFill/>
+            <a:prstDash val="solid"/>
+          </a:ln>
+        </p:spPr>
+        <p:txBody>
+          <a:bodyPr xmlns:a="http://schemas.openxmlformats.org/drawingml/2006/main" wrap="square" lIns="38100" tIns="19050" rIns="38100" bIns="19050" anchor="ctr">
+            <a:noAutofit/>
+          </a:bodyPr>
+          <a:lstStyle xmlns:a="http://schemas.openxmlformats.org/drawingml/2006/main"/>
+          <a:p xmlns:a="http://schemas.openxmlformats.org/drawingml/2006/main">
+            <a:pPr algn="ctr">
+              <a:defRPr sz="1400" b="1">
+                <a:solidFill>
+                  <a:srgbClr val="E8872D"/>
+                </a:solidFill>
+              </a:defRPr>
+            </a:pPr>
+            <a:r>
+              <a:rPr sz="1400" b="1">
+                <a:solidFill>
+                  <a:srgbClr val="E8872D"/>
+                </a:solidFill>
+              </a:rPr>
+              <a:t>100点</a:t>
+            </a:r>
+          </a:p>
+        </p:txBody>
+      </p:sp>
+      <p:sp>
+        <p:nvSpPr>
+          <p:cNvPr id="45" name="ratio-point-2">
+            <a:extLst xmlns:a="http://schemas.openxmlformats.org/drawingml/2006/main">
+              <a:ext uri="{FF2B5EF4-FFF2-40B4-BE49-F238E27FC236}">
+                <a16:creationId xmlns:a16="http://schemas.microsoft.com/office/drawing/2014/main" id="{FC2CE702-4ADB-4E9C-9A4E-1B833AF00060}"/>
+              </a:ext>
+            </a:extLst>
+          </p:cNvPr>
+          <p:cNvSpPr>
+            <a:spLocks xmlns:a="http://schemas.openxmlformats.org/drawingml/2006/main" noGrp="1"/>
+          </p:cNvSpPr>
+          <p:nvPr/>
+        </p:nvSpPr>
+        <p:spPr>
+          <a:xfrm xmlns:a="http://schemas.openxmlformats.org/drawingml/2006/main">
+            <a:off x="2700338" y="2750004"/>
             <a:ext cx="95250" cy="95250"/>
           </a:xfrm>
           <a:prstGeom xmlns:a="http://schemas.openxmlformats.org/drawingml/2006/main" prst="ellipse">
@@ -2818,7 +2908,9 @@
           </a:ln>
         </p:spPr>
         <p:txBody>
-          <a:bodyPr xmlns:a="http://schemas.openxmlformats.org/drawingml/2006/main" anchor="ctr"/>
+          <a:bodyPr xmlns:a="http://schemas.openxmlformats.org/drawingml/2006/main" wrap="square" lIns="38100" tIns="19050" rIns="38100" bIns="19050" anchor="ctr">
+            <a:noAutofit/>
+          </a:bodyPr>
           <a:lstStyle xmlns:a="http://schemas.openxmlformats.org/drawingml/2006/main"/>
           <a:p xmlns:a="http://schemas.openxmlformats.org/drawingml/2006/main">
             <a:r>
@@ -2829,21 +2921,73 @@
       </p:sp>
       <p:sp>
         <p:nvSpPr>
-          <p:cNvPr id="45" name="ratio-point-3">
-            <a:extLst xmlns:a="http://schemas.openxmlformats.org/drawingml/2006/main">
-              <a:ext uri="{FF2B5EF4-FFF2-40B4-BE49-F238E27FC236}">
-                <a16:creationId xmlns:a16="http://schemas.microsoft.com/office/drawing/2014/main" id="{8A44A834-28BE-4A44-944C-CC12A25D25D4}"/>
-              </a:ext>
-            </a:extLst>
-          </p:cNvPr>
-          <p:cNvSpPr>
-            <a:spLocks xmlns:a="http://schemas.openxmlformats.org/drawingml/2006/main" noGrp="1"/>
-          </p:cNvSpPr>
-          <p:nvPr/>
-        </p:nvSpPr>
-        <p:spPr>
-          <a:xfrm xmlns:a="http://schemas.openxmlformats.org/drawingml/2006/main">
-            <a:off x="3770313" y="3276600"/>
+          <p:cNvPr id="46" name="ratio-label-2">
+            <a:extLst xmlns:a="http://schemas.openxmlformats.org/drawingml/2006/main">
+              <a:ext uri="{FF2B5EF4-FFF2-40B4-BE49-F238E27FC236}">
+                <a16:creationId xmlns:a16="http://schemas.microsoft.com/office/drawing/2014/main" id="{853BD84F-7BFE-4DD9-8961-7B0554733917}"/>
+              </a:ext>
+            </a:extLst>
+          </p:cNvPr>
+          <p:cNvSpPr>
+            <a:spLocks xmlns:a="http://schemas.openxmlformats.org/drawingml/2006/main" noGrp="1"/>
+          </p:cNvSpPr>
+          <p:nvPr/>
+        </p:nvSpPr>
+        <p:spPr>
+          <a:xfrm xmlns:a="http://schemas.openxmlformats.org/drawingml/2006/main">
+            <a:off x="2424113" y="2540454"/>
+            <a:ext cx="647700" cy="209550"/>
+          </a:xfrm>
+          <a:prstGeom xmlns:a="http://schemas.openxmlformats.org/drawingml/2006/main" prst="rect">
+            <a:avLst/>
+          </a:prstGeom>
+          <a:noFill xmlns:a="http://schemas.openxmlformats.org/drawingml/2006/main"/>
+          <a:ln xmlns:a="http://schemas.openxmlformats.org/drawingml/2006/main" w="0">
+            <a:noFill/>
+            <a:prstDash val="solid"/>
+          </a:ln>
+        </p:spPr>
+        <p:txBody>
+          <a:bodyPr xmlns:a="http://schemas.openxmlformats.org/drawingml/2006/main" wrap="square" lIns="38100" tIns="19050" rIns="38100" bIns="19050" anchor="ctr">
+            <a:noAutofit/>
+          </a:bodyPr>
+          <a:lstStyle xmlns:a="http://schemas.openxmlformats.org/drawingml/2006/main"/>
+          <a:p xmlns:a="http://schemas.openxmlformats.org/drawingml/2006/main">
+            <a:pPr algn="ctr">
+              <a:defRPr sz="1400" b="1">
+                <a:solidFill>
+                  <a:srgbClr val="E8872D"/>
+                </a:solidFill>
+              </a:defRPr>
+            </a:pPr>
+            <a:r>
+              <a:rPr sz="1400" b="1">
+                <a:solidFill>
+                  <a:srgbClr val="E8872D"/>
+                </a:solidFill>
+              </a:rPr>
+              <a:t>95点</a:t>
+            </a:r>
+          </a:p>
+        </p:txBody>
+      </p:sp>
+      <p:sp>
+        <p:nvSpPr>
+          <p:cNvPr id="47" name="ratio-point-3">
+            <a:extLst xmlns:a="http://schemas.openxmlformats.org/drawingml/2006/main">
+              <a:ext uri="{FF2B5EF4-FFF2-40B4-BE49-F238E27FC236}">
+                <a16:creationId xmlns:a16="http://schemas.microsoft.com/office/drawing/2014/main" id="{665539F7-5E25-49BA-B5F3-1A0902807E92}"/>
+              </a:ext>
+            </a:extLst>
+          </p:cNvPr>
+          <p:cNvSpPr>
+            <a:spLocks xmlns:a="http://schemas.openxmlformats.org/drawingml/2006/main" noGrp="1"/>
+          </p:cNvSpPr>
+          <p:nvPr/>
+        </p:nvSpPr>
+        <p:spPr>
+          <a:xfrm xmlns:a="http://schemas.openxmlformats.org/drawingml/2006/main">
+            <a:off x="3770313" y="3241494"/>
             <a:ext cx="95250" cy="95250"/>
           </a:xfrm>
           <a:prstGeom xmlns:a="http://schemas.openxmlformats.org/drawingml/2006/main" prst="ellipse">
@@ -2860,7 +3004,9 @@
           </a:ln>
         </p:spPr>
         <p:txBody>
-          <a:bodyPr xmlns:a="http://schemas.openxmlformats.org/drawingml/2006/main" anchor="ctr"/>
+          <a:bodyPr xmlns:a="http://schemas.openxmlformats.org/drawingml/2006/main" wrap="square" lIns="38100" tIns="19050" rIns="38100" bIns="19050" anchor="ctr">
+            <a:noAutofit/>
+          </a:bodyPr>
           <a:lstStyle xmlns:a="http://schemas.openxmlformats.org/drawingml/2006/main"/>
           <a:p xmlns:a="http://schemas.openxmlformats.org/drawingml/2006/main">
             <a:r>
@@ -2871,21 +3017,73 @@
       </p:sp>
       <p:sp>
         <p:nvSpPr>
-          <p:cNvPr id="46" name="ratio-point-4">
-            <a:extLst xmlns:a="http://schemas.openxmlformats.org/drawingml/2006/main">
-              <a:ext uri="{FF2B5EF4-FFF2-40B4-BE49-F238E27FC236}">
-                <a16:creationId xmlns:a16="http://schemas.microsoft.com/office/drawing/2014/main" id="{FB0E16EF-C6AF-49CF-928C-B499133787D1}"/>
-              </a:ext>
-            </a:extLst>
-          </p:cNvPr>
-          <p:cNvSpPr>
-            <a:spLocks xmlns:a="http://schemas.openxmlformats.org/drawingml/2006/main" noGrp="1"/>
-          </p:cNvSpPr>
-          <p:nvPr/>
-        </p:nvSpPr>
-        <p:spPr>
-          <a:xfrm xmlns:a="http://schemas.openxmlformats.org/drawingml/2006/main">
-            <a:off x="4840288" y="3788569"/>
+          <p:cNvPr id="48" name="ratio-label-3">
+            <a:extLst xmlns:a="http://schemas.openxmlformats.org/drawingml/2006/main">
+              <a:ext uri="{FF2B5EF4-FFF2-40B4-BE49-F238E27FC236}">
+                <a16:creationId xmlns:a16="http://schemas.microsoft.com/office/drawing/2014/main" id="{8A330C3F-4C43-4025-92A2-D20310E0CAFF}"/>
+              </a:ext>
+            </a:extLst>
+          </p:cNvPr>
+          <p:cNvSpPr>
+            <a:spLocks xmlns:a="http://schemas.openxmlformats.org/drawingml/2006/main" noGrp="1"/>
+          </p:cNvSpPr>
+          <p:nvPr/>
+        </p:nvSpPr>
+        <p:spPr>
+          <a:xfrm xmlns:a="http://schemas.openxmlformats.org/drawingml/2006/main">
+            <a:off x="3494088" y="3031944"/>
+            <a:ext cx="647700" cy="209550"/>
+          </a:xfrm>
+          <a:prstGeom xmlns:a="http://schemas.openxmlformats.org/drawingml/2006/main" prst="rect">
+            <a:avLst/>
+          </a:prstGeom>
+          <a:noFill xmlns:a="http://schemas.openxmlformats.org/drawingml/2006/main"/>
+          <a:ln xmlns:a="http://schemas.openxmlformats.org/drawingml/2006/main" w="0">
+            <a:noFill/>
+            <a:prstDash val="solid"/>
+          </a:ln>
+        </p:spPr>
+        <p:txBody>
+          <a:bodyPr xmlns:a="http://schemas.openxmlformats.org/drawingml/2006/main" wrap="square" lIns="38100" tIns="19050" rIns="38100" bIns="19050" anchor="ctr">
+            <a:noAutofit/>
+          </a:bodyPr>
+          <a:lstStyle xmlns:a="http://schemas.openxmlformats.org/drawingml/2006/main"/>
+          <a:p xmlns:a="http://schemas.openxmlformats.org/drawingml/2006/main">
+            <a:pPr algn="ctr">
+              <a:defRPr sz="1400" b="1">
+                <a:solidFill>
+                  <a:srgbClr val="E8872D"/>
+                </a:solidFill>
+              </a:defRPr>
+            </a:pPr>
+            <a:r>
+              <a:rPr sz="1400" b="1">
+                <a:solidFill>
+                  <a:srgbClr val="E8872D"/>
+                </a:solidFill>
+              </a:rPr>
+              <a:t>88点</a:t>
+            </a:r>
+          </a:p>
+        </p:txBody>
+      </p:sp>
+      <p:sp>
+        <p:nvSpPr>
+          <p:cNvPr id="49" name="ratio-point-4">
+            <a:extLst xmlns:a="http://schemas.openxmlformats.org/drawingml/2006/main">
+              <a:ext uri="{FF2B5EF4-FFF2-40B4-BE49-F238E27FC236}">
+                <a16:creationId xmlns:a16="http://schemas.microsoft.com/office/drawing/2014/main" id="{5DF5D13F-4D39-4FB4-8988-A8E9CAB70C30}"/>
+              </a:ext>
+            </a:extLst>
+          </p:cNvPr>
+          <p:cNvSpPr>
+            <a:spLocks xmlns:a="http://schemas.openxmlformats.org/drawingml/2006/main" noGrp="1"/>
+          </p:cNvSpPr>
+          <p:nvPr/>
+        </p:nvSpPr>
+        <p:spPr>
+          <a:xfrm xmlns:a="http://schemas.openxmlformats.org/drawingml/2006/main">
+            <a:off x="4840288" y="3592558"/>
             <a:ext cx="95250" cy="95250"/>
           </a:xfrm>
           <a:prstGeom xmlns:a="http://schemas.openxmlformats.org/drawingml/2006/main" prst="ellipse">
@@ -2902,7 +3100,9 @@
           </a:ln>
         </p:spPr>
         <p:txBody>
-          <a:bodyPr xmlns:a="http://schemas.openxmlformats.org/drawingml/2006/main" anchor="ctr"/>
+          <a:bodyPr xmlns:a="http://schemas.openxmlformats.org/drawingml/2006/main" wrap="square" lIns="38100" tIns="19050" rIns="38100" bIns="19050" anchor="ctr">
+            <a:noAutofit/>
+          </a:bodyPr>
           <a:lstStyle xmlns:a="http://schemas.openxmlformats.org/drawingml/2006/main"/>
           <a:p xmlns:a="http://schemas.openxmlformats.org/drawingml/2006/main">
             <a:r>
@@ -2913,21 +3113,73 @@
       </p:sp>
       <p:sp>
         <p:nvSpPr>
-          <p:cNvPr id="47" name="ratio-point-5">
-            <a:extLst xmlns:a="http://schemas.openxmlformats.org/drawingml/2006/main">
-              <a:ext uri="{FF2B5EF4-FFF2-40B4-BE49-F238E27FC236}">
-                <a16:creationId xmlns:a16="http://schemas.microsoft.com/office/drawing/2014/main" id="{684D4CDA-80F4-41C9-B892-451DD7178617}"/>
-              </a:ext>
-            </a:extLst>
-          </p:cNvPr>
-          <p:cNvSpPr>
-            <a:spLocks xmlns:a="http://schemas.openxmlformats.org/drawingml/2006/main" noGrp="1"/>
-          </p:cNvSpPr>
-          <p:nvPr/>
-        </p:nvSpPr>
-        <p:spPr>
-          <a:xfrm xmlns:a="http://schemas.openxmlformats.org/drawingml/2006/main">
-            <a:off x="5910263" y="4198144"/>
+          <p:cNvPr id="50" name="ratio-label-4">
+            <a:extLst xmlns:a="http://schemas.openxmlformats.org/drawingml/2006/main">
+              <a:ext uri="{FF2B5EF4-FFF2-40B4-BE49-F238E27FC236}">
+                <a16:creationId xmlns:a16="http://schemas.microsoft.com/office/drawing/2014/main" id="{284C5C87-9335-4092-9ABD-7A6496D1B36D}"/>
+              </a:ext>
+            </a:extLst>
+          </p:cNvPr>
+          <p:cNvSpPr>
+            <a:spLocks xmlns:a="http://schemas.openxmlformats.org/drawingml/2006/main" noGrp="1"/>
+          </p:cNvSpPr>
+          <p:nvPr/>
+        </p:nvSpPr>
+        <p:spPr>
+          <a:xfrm xmlns:a="http://schemas.openxmlformats.org/drawingml/2006/main">
+            <a:off x="4564063" y="3383008"/>
+            <a:ext cx="647700" cy="209550"/>
+          </a:xfrm>
+          <a:prstGeom xmlns:a="http://schemas.openxmlformats.org/drawingml/2006/main" prst="rect">
+            <a:avLst/>
+          </a:prstGeom>
+          <a:noFill xmlns:a="http://schemas.openxmlformats.org/drawingml/2006/main"/>
+          <a:ln xmlns:a="http://schemas.openxmlformats.org/drawingml/2006/main" w="0">
+            <a:noFill/>
+            <a:prstDash val="solid"/>
+          </a:ln>
+        </p:spPr>
+        <p:txBody>
+          <a:bodyPr xmlns:a="http://schemas.openxmlformats.org/drawingml/2006/main" wrap="square" lIns="38100" tIns="19050" rIns="38100" bIns="19050" anchor="ctr">
+            <a:noAutofit/>
+          </a:bodyPr>
+          <a:lstStyle xmlns:a="http://schemas.openxmlformats.org/drawingml/2006/main"/>
+          <a:p xmlns:a="http://schemas.openxmlformats.org/drawingml/2006/main">
+            <a:pPr algn="ctr">
+              <a:defRPr sz="1400" b="1">
+                <a:solidFill>
+                  <a:srgbClr val="E8872D"/>
+                </a:solidFill>
+              </a:defRPr>
+            </a:pPr>
+            <a:r>
+              <a:rPr sz="1400" b="1">
+                <a:solidFill>
+                  <a:srgbClr val="E8872D"/>
+                </a:solidFill>
+              </a:rPr>
+              <a:t>83点</a:t>
+            </a:r>
+          </a:p>
+        </p:txBody>
+      </p:sp>
+      <p:sp>
+        <p:nvSpPr>
+          <p:cNvPr id="51" name="ratio-point-5">
+            <a:extLst xmlns:a="http://schemas.openxmlformats.org/drawingml/2006/main">
+              <a:ext uri="{FF2B5EF4-FFF2-40B4-BE49-F238E27FC236}">
+                <a16:creationId xmlns:a16="http://schemas.microsoft.com/office/drawing/2014/main" id="{BD69CD9D-570B-4DA9-B5F8-691BF743EE21}"/>
+              </a:ext>
+            </a:extLst>
+          </p:cNvPr>
+          <p:cNvSpPr>
+            <a:spLocks xmlns:a="http://schemas.openxmlformats.org/drawingml/2006/main" noGrp="1"/>
+          </p:cNvSpPr>
+          <p:nvPr/>
+        </p:nvSpPr>
+        <p:spPr>
+          <a:xfrm xmlns:a="http://schemas.openxmlformats.org/drawingml/2006/main">
+            <a:off x="5910263" y="3873409"/>
             <a:ext cx="95250" cy="95250"/>
           </a:xfrm>
           <a:prstGeom xmlns:a="http://schemas.openxmlformats.org/drawingml/2006/main" prst="ellipse">
@@ -2944,7 +3196,9 @@
           </a:ln>
         </p:spPr>
         <p:txBody>
-          <a:bodyPr xmlns:a="http://schemas.openxmlformats.org/drawingml/2006/main" anchor="ctr"/>
+          <a:bodyPr xmlns:a="http://schemas.openxmlformats.org/drawingml/2006/main" wrap="square" lIns="38100" tIns="19050" rIns="38100" bIns="19050" anchor="ctr">
+            <a:noAutofit/>
+          </a:bodyPr>
           <a:lstStyle xmlns:a="http://schemas.openxmlformats.org/drawingml/2006/main"/>
           <a:p xmlns:a="http://schemas.openxmlformats.org/drawingml/2006/main">
             <a:r>
@@ -2955,21 +3209,73 @@
       </p:sp>
       <p:sp>
         <p:nvSpPr>
-          <p:cNvPr id="48" name="ratio-point-6">
-            <a:extLst xmlns:a="http://schemas.openxmlformats.org/drawingml/2006/main">
-              <a:ext uri="{FF2B5EF4-FFF2-40B4-BE49-F238E27FC236}">
-                <a16:creationId xmlns:a16="http://schemas.microsoft.com/office/drawing/2014/main" id="{0E41C902-DE27-4577-9CD5-011FC148C56F}"/>
-              </a:ext>
-            </a:extLst>
-          </p:cNvPr>
-          <p:cNvSpPr>
-            <a:spLocks xmlns:a="http://schemas.openxmlformats.org/drawingml/2006/main" noGrp="1"/>
-          </p:cNvSpPr>
-          <p:nvPr/>
-        </p:nvSpPr>
-        <p:spPr>
-          <a:xfrm xmlns:a="http://schemas.openxmlformats.org/drawingml/2006/main">
-            <a:off x="6980237" y="4505325"/>
+          <p:cNvPr id="52" name="ratio-label-5">
+            <a:extLst xmlns:a="http://schemas.openxmlformats.org/drawingml/2006/main">
+              <a:ext uri="{FF2B5EF4-FFF2-40B4-BE49-F238E27FC236}">
+                <a16:creationId xmlns:a16="http://schemas.microsoft.com/office/drawing/2014/main" id="{03DC7949-F7CD-47FE-9392-150817770BE5}"/>
+              </a:ext>
+            </a:extLst>
+          </p:cNvPr>
+          <p:cNvSpPr>
+            <a:spLocks xmlns:a="http://schemas.openxmlformats.org/drawingml/2006/main" noGrp="1"/>
+          </p:cNvSpPr>
+          <p:nvPr/>
+        </p:nvSpPr>
+        <p:spPr>
+          <a:xfrm xmlns:a="http://schemas.openxmlformats.org/drawingml/2006/main">
+            <a:off x="5634038" y="3663859"/>
+            <a:ext cx="647700" cy="209550"/>
+          </a:xfrm>
+          <a:prstGeom xmlns:a="http://schemas.openxmlformats.org/drawingml/2006/main" prst="rect">
+            <a:avLst/>
+          </a:prstGeom>
+          <a:noFill xmlns:a="http://schemas.openxmlformats.org/drawingml/2006/main"/>
+          <a:ln xmlns:a="http://schemas.openxmlformats.org/drawingml/2006/main" w="0">
+            <a:noFill/>
+            <a:prstDash val="solid"/>
+          </a:ln>
+        </p:spPr>
+        <p:txBody>
+          <a:bodyPr xmlns:a="http://schemas.openxmlformats.org/drawingml/2006/main" wrap="square" lIns="38100" tIns="19050" rIns="38100" bIns="19050" anchor="ctr">
+            <a:noAutofit/>
+          </a:bodyPr>
+          <a:lstStyle xmlns:a="http://schemas.openxmlformats.org/drawingml/2006/main"/>
+          <a:p xmlns:a="http://schemas.openxmlformats.org/drawingml/2006/main">
+            <a:pPr algn="ctr">
+              <a:defRPr sz="1400" b="1">
+                <a:solidFill>
+                  <a:srgbClr val="E8872D"/>
+                </a:solidFill>
+              </a:defRPr>
+            </a:pPr>
+            <a:r>
+              <a:rPr sz="1400" b="1">
+                <a:solidFill>
+                  <a:srgbClr val="E8872D"/>
+                </a:solidFill>
+              </a:rPr>
+              <a:t>79点</a:t>
+            </a:r>
+          </a:p>
+        </p:txBody>
+      </p:sp>
+      <p:sp>
+        <p:nvSpPr>
+          <p:cNvPr id="53" name="ratio-point-6">
+            <a:extLst xmlns:a="http://schemas.openxmlformats.org/drawingml/2006/main">
+              <a:ext uri="{FF2B5EF4-FFF2-40B4-BE49-F238E27FC236}">
+                <a16:creationId xmlns:a16="http://schemas.microsoft.com/office/drawing/2014/main" id="{D4D756CB-7C40-4942-AF42-5FBA2A936C51}"/>
+              </a:ext>
+            </a:extLst>
+          </p:cNvPr>
+          <p:cNvSpPr>
+            <a:spLocks xmlns:a="http://schemas.openxmlformats.org/drawingml/2006/main" noGrp="1"/>
+          </p:cNvSpPr>
+          <p:nvPr/>
+        </p:nvSpPr>
+        <p:spPr>
+          <a:xfrm xmlns:a="http://schemas.openxmlformats.org/drawingml/2006/main">
+            <a:off x="6980237" y="4084048"/>
             <a:ext cx="95250" cy="95250"/>
           </a:xfrm>
           <a:prstGeom xmlns:a="http://schemas.openxmlformats.org/drawingml/2006/main" prst="ellipse">
@@ -2986,7 +3292,9 @@
           </a:ln>
         </p:spPr>
         <p:txBody>
-          <a:bodyPr xmlns:a="http://schemas.openxmlformats.org/drawingml/2006/main" anchor="ctr"/>
+          <a:bodyPr xmlns:a="http://schemas.openxmlformats.org/drawingml/2006/main" wrap="square" lIns="38100" tIns="19050" rIns="38100" bIns="19050" anchor="ctr">
+            <a:noAutofit/>
+          </a:bodyPr>
           <a:lstStyle xmlns:a="http://schemas.openxmlformats.org/drawingml/2006/main"/>
           <a:p xmlns:a="http://schemas.openxmlformats.org/drawingml/2006/main">
             <a:r>
@@ -2997,22 +3305,22 @@
       </p:sp>
       <p:sp>
         <p:nvSpPr>
-          <p:cNvPr id="49" name="legend">
-            <a:extLst xmlns:a="http://schemas.openxmlformats.org/drawingml/2006/main">
-              <a:ext uri="{FF2B5EF4-FFF2-40B4-BE49-F238E27FC236}">
-                <a16:creationId xmlns:a16="http://schemas.microsoft.com/office/drawing/2014/main" id="{619C2709-316F-4742-8DDD-18EB6C0762D5}"/>
-              </a:ext>
-            </a:extLst>
-          </p:cNvPr>
-          <p:cNvSpPr>
-            <a:spLocks xmlns:a="http://schemas.openxmlformats.org/drawingml/2006/main" noGrp="1"/>
-          </p:cNvSpPr>
-          <p:nvPr/>
-        </p:nvSpPr>
-        <p:spPr>
-          <a:xfrm xmlns:a="http://schemas.openxmlformats.org/drawingml/2006/main">
-            <a:off x="3829050" y="1485900"/>
-            <a:ext cx="3714750" cy="266700"/>
+          <p:cNvPr id="54" name="ratio-label-6">
+            <a:extLst xmlns:a="http://schemas.openxmlformats.org/drawingml/2006/main">
+              <a:ext uri="{FF2B5EF4-FFF2-40B4-BE49-F238E27FC236}">
+                <a16:creationId xmlns:a16="http://schemas.microsoft.com/office/drawing/2014/main" id="{D4FE3BCD-CB5E-4874-B840-38623A9C6E8F}"/>
+              </a:ext>
+            </a:extLst>
+          </p:cNvPr>
+          <p:cNvSpPr>
+            <a:spLocks xmlns:a="http://schemas.openxmlformats.org/drawingml/2006/main" noGrp="1"/>
+          </p:cNvSpPr>
+          <p:nvPr/>
+        </p:nvSpPr>
+        <p:spPr>
+          <a:xfrm xmlns:a="http://schemas.openxmlformats.org/drawingml/2006/main">
+            <a:off x="6704012" y="3874498"/>
+            <a:ext cx="647700" cy="209550"/>
           </a:xfrm>
           <a:prstGeom xmlns:a="http://schemas.openxmlformats.org/drawingml/2006/main" prst="rect">
             <a:avLst/>
@@ -3024,7 +3332,61 @@
           </a:ln>
         </p:spPr>
         <p:txBody>
-          <a:bodyPr xmlns:a="http://schemas.openxmlformats.org/drawingml/2006/main" anchor="ctr"/>
+          <a:bodyPr xmlns:a="http://schemas.openxmlformats.org/drawingml/2006/main" wrap="square" lIns="38100" tIns="19050" rIns="38100" bIns="19050" anchor="ctr">
+            <a:noAutofit/>
+          </a:bodyPr>
+          <a:lstStyle xmlns:a="http://schemas.openxmlformats.org/drawingml/2006/main"/>
+          <a:p xmlns:a="http://schemas.openxmlformats.org/drawingml/2006/main">
+            <a:pPr algn="ctr">
+              <a:defRPr sz="1400" b="1">
+                <a:solidFill>
+                  <a:srgbClr val="E8872D"/>
+                </a:solidFill>
+              </a:defRPr>
+            </a:pPr>
+            <a:r>
+              <a:rPr sz="1400" b="1">
+                <a:solidFill>
+                  <a:srgbClr val="E8872D"/>
+                </a:solidFill>
+              </a:rPr>
+              <a:t>76点</a:t>
+            </a:r>
+          </a:p>
+        </p:txBody>
+      </p:sp>
+      <p:sp>
+        <p:nvSpPr>
+          <p:cNvPr id="55" name="legend">
+            <a:extLst xmlns:a="http://schemas.openxmlformats.org/drawingml/2006/main">
+              <a:ext uri="{FF2B5EF4-FFF2-40B4-BE49-F238E27FC236}">
+                <a16:creationId xmlns:a16="http://schemas.microsoft.com/office/drawing/2014/main" id="{500607FE-DB74-4279-86BB-E8725CB432A6}"/>
+              </a:ext>
+            </a:extLst>
+          </p:cNvPr>
+          <p:cNvSpPr>
+            <a:spLocks xmlns:a="http://schemas.openxmlformats.org/drawingml/2006/main" noGrp="1"/>
+          </p:cNvSpPr>
+          <p:nvPr/>
+        </p:nvSpPr>
+        <p:spPr>
+          <a:xfrm xmlns:a="http://schemas.openxmlformats.org/drawingml/2006/main">
+            <a:off x="762000" y="1485900"/>
+            <a:ext cx="6896100" cy="266700"/>
+          </a:xfrm>
+          <a:prstGeom xmlns:a="http://schemas.openxmlformats.org/drawingml/2006/main" prst="rect">
+            <a:avLst/>
+          </a:prstGeom>
+          <a:noFill xmlns:a="http://schemas.openxmlformats.org/drawingml/2006/main"/>
+          <a:ln xmlns:a="http://schemas.openxmlformats.org/drawingml/2006/main" w="0">
+            <a:noFill/>
+            <a:prstDash val="solid"/>
+          </a:ln>
+        </p:spPr>
+        <p:txBody>
+          <a:bodyPr xmlns:a="http://schemas.openxmlformats.org/drawingml/2006/main" wrap="square" lIns="38100" tIns="19050" rIns="38100" bIns="19050" anchor="ctr">
+            <a:noAutofit/>
+          </a:bodyPr>
           <a:lstStyle xmlns:a="http://schemas.openxmlformats.org/drawingml/2006/main"/>
           <a:p xmlns:a="http://schemas.openxmlformats.org/drawingml/2006/main">
             <a:pPr algn="r">
@@ -3047,10 +3409,10 @@
       </p:sp>
       <p:sp>
         <p:nvSpPr>
-          <p:cNvPr id="50" name="insight-rail">
-            <a:extLst xmlns:a="http://schemas.openxmlformats.org/drawingml/2006/main">
-              <a:ext uri="{FF2B5EF4-FFF2-40B4-BE49-F238E27FC236}">
-                <a16:creationId xmlns:a16="http://schemas.microsoft.com/office/drawing/2014/main" id="{0D0904AE-3BB6-43E1-9C3E-A31D106DA54A}"/>
+          <p:cNvPr id="56" name="insight-rail">
+            <a:extLst xmlns:a="http://schemas.openxmlformats.org/drawingml/2006/main">
+              <a:ext uri="{FF2B5EF4-FFF2-40B4-BE49-F238E27FC236}">
+                <a16:creationId xmlns:a16="http://schemas.microsoft.com/office/drawing/2014/main" id="{A2C46242-52F5-4615-8AE6-E51E6901C399}"/>
               </a:ext>
             </a:extLst>
           </p:cNvPr>
@@ -3064,10 +3426,8 @@
             <a:off x="8096250" y="1238250"/>
             <a:ext cx="3581400" cy="4381500"/>
           </a:xfrm>
-          <a:prstGeom xmlns:a="http://schemas.openxmlformats.org/drawingml/2006/main" prst="roundRect">
-            <a:avLst>
-              <a:gd name="adj" fmla="val 2128"/>
-            </a:avLst>
+          <a:prstGeom xmlns:a="http://schemas.openxmlformats.org/drawingml/2006/main" prst="rect">
+            <a:avLst/>
           </a:prstGeom>
           <a:solidFill xmlns:a="http://schemas.openxmlformats.org/drawingml/2006/main">
             <a:srgbClr val="F4F6F8"/>
@@ -3082,10 +3442,10 @@
       </p:sp>
       <p:sp>
         <p:nvSpPr>
-          <p:cNvPr id="51" name="insight-title">
-            <a:extLst xmlns:a="http://schemas.openxmlformats.org/drawingml/2006/main">
-              <a:ext uri="{FF2B5EF4-FFF2-40B4-BE49-F238E27FC236}">
-                <a16:creationId xmlns:a16="http://schemas.microsoft.com/office/drawing/2014/main" id="{A162A0B3-BE4B-44DF-A132-0C9A8D81153C}"/>
+          <p:cNvPr id="57" name="insight-title">
+            <a:extLst xmlns:a="http://schemas.openxmlformats.org/drawingml/2006/main">
+              <a:ext uri="{FF2B5EF4-FFF2-40B4-BE49-F238E27FC236}">
+                <a16:creationId xmlns:a16="http://schemas.microsoft.com/office/drawing/2014/main" id="{D9A21760-4090-4FC7-A1B1-5671FD26E897}"/>
               </a:ext>
             </a:extLst>
           </p:cNvPr>
@@ -3109,18 +3469,20 @@
           </a:ln>
         </p:spPr>
         <p:txBody>
-          <a:bodyPr xmlns:a="http://schemas.openxmlformats.org/drawingml/2006/main" anchor="ctr"/>
+          <a:bodyPr xmlns:a="http://schemas.openxmlformats.org/drawingml/2006/main" wrap="square" lIns="38100" tIns="19050" rIns="38100" bIns="19050" anchor="ctr">
+            <a:noAutofit/>
+          </a:bodyPr>
           <a:lstStyle xmlns:a="http://schemas.openxmlformats.org/drawingml/2006/main"/>
           <a:p xmlns:a="http://schemas.openxmlformats.org/drawingml/2006/main">
             <a:pPr algn="l">
-              <a:defRPr sz="1600" b="1">
+              <a:defRPr sz="1800" b="1">
                 <a:solidFill>
                   <a:srgbClr val="15375F"/>
                 </a:solidFill>
               </a:defRPr>
             </a:pPr>
             <a:r>
-              <a:rPr sz="1600" b="1">
+              <a:rPr sz="1800" b="1">
                 <a:solidFill>
                   <a:srgbClr val="15375F"/>
                 </a:solidFill>
@@ -3132,10 +3494,10 @@
       </p:sp>
       <p:sp>
         <p:nvSpPr>
-          <p:cNvPr id="52" name="insight-1">
-            <a:extLst xmlns:a="http://schemas.openxmlformats.org/drawingml/2006/main">
-              <a:ext uri="{FF2B5EF4-FFF2-40B4-BE49-F238E27FC236}">
-                <a16:creationId xmlns:a16="http://schemas.microsoft.com/office/drawing/2014/main" id="{AFFD7969-2507-4196-BAAD-4557CCC32B8A}"/>
+          <p:cNvPr id="58" name="insight-1">
+            <a:extLst xmlns:a="http://schemas.openxmlformats.org/drawingml/2006/main">
+              <a:ext uri="{FF2B5EF4-FFF2-40B4-BE49-F238E27FC236}">
+                <a16:creationId xmlns:a16="http://schemas.microsoft.com/office/drawing/2014/main" id="{8E8EABE2-63CC-4D3F-9214-89A95E090D78}"/>
               </a:ext>
             </a:extLst>
           </p:cNvPr>
@@ -3149,10 +3511,8 @@
             <a:off x="8286750" y="1866900"/>
             <a:ext cx="3200400" cy="876300"/>
           </a:xfrm>
-          <a:prstGeom xmlns:a="http://schemas.openxmlformats.org/drawingml/2006/main" prst="roundRect">
-            <a:avLst>
-              <a:gd name="adj" fmla="val 8696"/>
-            </a:avLst>
+          <a:prstGeom xmlns:a="http://schemas.openxmlformats.org/drawingml/2006/main" prst="rect">
+            <a:avLst/>
           </a:prstGeom>
           <a:solidFill xmlns:a="http://schemas.openxmlformats.org/drawingml/2006/main">
             <a:srgbClr val="FFFFFF"/>
@@ -3165,18 +3525,20 @@
           </a:ln>
         </p:spPr>
         <p:txBody>
-          <a:bodyPr xmlns:a="http://schemas.openxmlformats.org/drawingml/2006/main" anchor="ctr"/>
+          <a:bodyPr xmlns:a="http://schemas.openxmlformats.org/drawingml/2006/main" wrap="square" lIns="38100" tIns="19050" rIns="38100" bIns="19050" anchor="ctr">
+            <a:noAutofit/>
+          </a:bodyPr>
           <a:lstStyle xmlns:a="http://schemas.openxmlformats.org/drawingml/2006/main"/>
           <a:p xmlns:a="http://schemas.openxmlformats.org/drawingml/2006/main">
             <a:pPr algn="l">
-              <a:defRPr sz="1600" b="1">
+              <a:defRPr sz="1800" b="1">
                 <a:solidFill>
                   <a:srgbClr val="172033"/>
                 </a:solidFill>
               </a:defRPr>
             </a:pPr>
             <a:r>
-              <a:rPr sz="1600" b="1">
+              <a:rPr sz="1800" b="1">
                 <a:solidFill>
                   <a:srgbClr val="172033"/>
                 </a:solidFill>
@@ -3188,10 +3550,10 @@
       </p:sp>
       <p:sp>
         <p:nvSpPr>
-          <p:cNvPr id="54" name="insight-2">
-            <a:extLst xmlns:a="http://schemas.openxmlformats.org/drawingml/2006/main">
-              <a:ext uri="{FF2B5EF4-FFF2-40B4-BE49-F238E27FC236}">
-                <a16:creationId xmlns:a16="http://schemas.microsoft.com/office/drawing/2014/main" id="{E0F01867-810D-4B1B-A4C5-D8D9B99A4C9C}"/>
+          <p:cNvPr id="60" name="insight-2">
+            <a:extLst xmlns:a="http://schemas.openxmlformats.org/drawingml/2006/main">
+              <a:ext uri="{FF2B5EF4-FFF2-40B4-BE49-F238E27FC236}">
+                <a16:creationId xmlns:a16="http://schemas.microsoft.com/office/drawing/2014/main" id="{BF5D2D60-A408-4DEF-BCEB-75650C2E7412}"/>
               </a:ext>
             </a:extLst>
           </p:cNvPr>
@@ -3205,10 +3567,8 @@
             <a:off x="8286750" y="2981325"/>
             <a:ext cx="3200400" cy="876300"/>
           </a:xfrm>
-          <a:prstGeom xmlns:a="http://schemas.openxmlformats.org/drawingml/2006/main" prst="roundRect">
-            <a:avLst>
-              <a:gd name="adj" fmla="val 8696"/>
-            </a:avLst>
+          <a:prstGeom xmlns:a="http://schemas.openxmlformats.org/drawingml/2006/main" prst="rect">
+            <a:avLst/>
           </a:prstGeom>
           <a:solidFill xmlns:a="http://schemas.openxmlformats.org/drawingml/2006/main">
             <a:srgbClr val="FFFFFF"/>
@@ -3221,18 +3581,20 @@
           </a:ln>
         </p:spPr>
         <p:txBody>
-          <a:bodyPr xmlns:a="http://schemas.openxmlformats.org/drawingml/2006/main" anchor="ctr"/>
+          <a:bodyPr xmlns:a="http://schemas.openxmlformats.org/drawingml/2006/main" wrap="square" lIns="38100" tIns="19050" rIns="38100" bIns="19050" anchor="ctr">
+            <a:noAutofit/>
+          </a:bodyPr>
           <a:lstStyle xmlns:a="http://schemas.openxmlformats.org/drawingml/2006/main"/>
           <a:p xmlns:a="http://schemas.openxmlformats.org/drawingml/2006/main">
             <a:pPr algn="l">
-              <a:defRPr sz="1600" b="0">
+              <a:defRPr sz="1800" b="0">
                 <a:solidFill>
                   <a:srgbClr val="172033"/>
                 </a:solidFill>
               </a:defRPr>
             </a:pPr>
             <a:r>
-              <a:rPr sz="1600" b="0">
+              <a:rPr sz="1800" b="0">
                 <a:solidFill>
                   <a:srgbClr val="172033"/>
                 </a:solidFill>
@@ -3244,10 +3606,10 @@
       </p:sp>
       <p:sp>
         <p:nvSpPr>
-          <p:cNvPr id="56" name="insight-3">
-            <a:extLst xmlns:a="http://schemas.openxmlformats.org/drawingml/2006/main">
-              <a:ext uri="{FF2B5EF4-FFF2-40B4-BE49-F238E27FC236}">
-                <a16:creationId xmlns:a16="http://schemas.microsoft.com/office/drawing/2014/main" id="{F8EE27F7-A246-49C8-9D57-0180B69E84D8}"/>
+          <p:cNvPr id="62" name="insight-3">
+            <a:extLst xmlns:a="http://schemas.openxmlformats.org/drawingml/2006/main">
+              <a:ext uri="{FF2B5EF4-FFF2-40B4-BE49-F238E27FC236}">
+                <a16:creationId xmlns:a16="http://schemas.microsoft.com/office/drawing/2014/main" id="{63DFC4AA-6F00-4838-8280-04DBE1BC6FE3}"/>
               </a:ext>
             </a:extLst>
           </p:cNvPr>
@@ -3261,10 +3623,8 @@
             <a:off x="8286750" y="4095750"/>
             <a:ext cx="3200400" cy="876300"/>
           </a:xfrm>
-          <a:prstGeom xmlns:a="http://schemas.openxmlformats.org/drawingml/2006/main" prst="roundRect">
-            <a:avLst>
-              <a:gd name="adj" fmla="val 8696"/>
-            </a:avLst>
+          <a:prstGeom xmlns:a="http://schemas.openxmlformats.org/drawingml/2006/main" prst="rect">
+            <a:avLst/>
           </a:prstGeom>
           <a:solidFill xmlns:a="http://schemas.openxmlformats.org/drawingml/2006/main">
             <a:srgbClr val="FFFFFF"/>
@@ -3277,18 +3637,20 @@
           </a:ln>
         </p:spPr>
         <p:txBody>
-          <a:bodyPr xmlns:a="http://schemas.openxmlformats.org/drawingml/2006/main" anchor="ctr"/>
+          <a:bodyPr xmlns:a="http://schemas.openxmlformats.org/drawingml/2006/main" wrap="square" lIns="38100" tIns="19050" rIns="38100" bIns="19050" anchor="ctr">
+            <a:noAutofit/>
+          </a:bodyPr>
           <a:lstStyle xmlns:a="http://schemas.openxmlformats.org/drawingml/2006/main"/>
           <a:p xmlns:a="http://schemas.openxmlformats.org/drawingml/2006/main">
             <a:pPr algn="l">
-              <a:defRPr sz="1600" b="0">
+              <a:defRPr sz="1800" b="0">
                 <a:solidFill>
                   <a:srgbClr val="172033"/>
                 </a:solidFill>
               </a:defRPr>
             </a:pPr>
             <a:r>
-              <a:rPr sz="1600" b="0">
+              <a:rPr sz="1800" b="0">
                 <a:solidFill>
                   <a:srgbClr val="172033"/>
                 </a:solidFill>
@@ -3300,10 +3662,10 @@
       </p:sp>
       <p:sp>
         <p:nvSpPr>
-          <p:cNvPr id="58" name="conclusion">
-            <a:extLst xmlns:a="http://schemas.openxmlformats.org/drawingml/2006/main">
-              <a:ext uri="{FF2B5EF4-FFF2-40B4-BE49-F238E27FC236}">
-                <a16:creationId xmlns:a16="http://schemas.microsoft.com/office/drawing/2014/main" id="{84F45543-39C9-484D-BC53-3F5E4F09C028}"/>
+          <p:cNvPr id="64" name="conclusion">
+            <a:extLst xmlns:a="http://schemas.openxmlformats.org/drawingml/2006/main">
+              <a:ext uri="{FF2B5EF4-FFF2-40B4-BE49-F238E27FC236}">
+                <a16:creationId xmlns:a16="http://schemas.microsoft.com/office/drawing/2014/main" id="{861F9C81-E7C6-4149-8674-FC65FF49B180}"/>
               </a:ext>
             </a:extLst>
           </p:cNvPr>
@@ -3317,10 +3679,8 @@
             <a:off x="514350" y="5848350"/>
             <a:ext cx="11163300" cy="457200"/>
           </a:xfrm>
-          <a:prstGeom xmlns:a="http://schemas.openxmlformats.org/drawingml/2006/main" prst="roundRect">
-            <a:avLst>
-              <a:gd name="adj" fmla="val 16667"/>
-            </a:avLst>
+          <a:prstGeom xmlns:a="http://schemas.openxmlformats.org/drawingml/2006/main" prst="rect">
+            <a:avLst/>
           </a:prstGeom>
           <a:solidFill xmlns:a="http://schemas.openxmlformats.org/drawingml/2006/main">
             <a:srgbClr val="FFF0E2"/>
@@ -3333,18 +3693,20 @@
           </a:ln>
         </p:spPr>
         <p:txBody>
-          <a:bodyPr xmlns:a="http://schemas.openxmlformats.org/drawingml/2006/main" anchor="ctr"/>
+          <a:bodyPr xmlns:a="http://schemas.openxmlformats.org/drawingml/2006/main" wrap="square" lIns="38100" tIns="19050" rIns="38100" bIns="19050" anchor="ctr">
+            <a:noAutofit/>
+          </a:bodyPr>
           <a:lstStyle xmlns:a="http://schemas.openxmlformats.org/drawingml/2006/main"/>
           <a:p xmlns:a="http://schemas.openxmlformats.org/drawingml/2006/main">
             <a:pPr algn="ctr">
-              <a:defRPr sz="1600" b="1">
+              <a:defRPr sz="1800" b="1">
                 <a:solidFill>
                   <a:srgbClr val="15375F"/>
                 </a:solidFill>
               </a:defRPr>
             </a:pPr>
             <a:r>
-              <a:rPr sz="1600" b="1">
+              <a:rPr sz="1800" b="1">
                 <a:solidFill>
                   <a:srgbClr val="15375F"/>
                 </a:solidFill>
@@ -3356,9 +3718,9 @@
       </p:sp>
       <p:cxnSp>
         <p:nvCxnSpPr>
-          <p:cNvPr id="114" name=""/>
+          <p:cNvPr id="126" name=""/>
           <p:cNvCxnSpPr>
-            <a:stCxn xmlns:a="http://schemas.openxmlformats.org/drawingml/2006/main" id="52" idx="1"/>
+            <a:stCxn xmlns:a="http://schemas.openxmlformats.org/drawingml/2006/main" id="58" idx="1"/>
             <a:endCxn xmlns:a="http://schemas.openxmlformats.org/drawingml/2006/main" id="33" idx="3"/>
           </p:cNvCxnSpPr>
           <p:nvPr/>
@@ -3381,17 +3743,17 @@
       </p:cxnSp>
       <p:cxnSp>
         <p:nvCxnSpPr>
-          <p:cNvPr id="115" name=""/>
+          <p:cNvPr id="127" name=""/>
           <p:cNvCxnSpPr>
-            <a:stCxn xmlns:a="http://schemas.openxmlformats.org/drawingml/2006/main" id="54" idx="1"/>
-            <a:endCxn xmlns:a="http://schemas.openxmlformats.org/drawingml/2006/main" id="23" idx="3"/>
+            <a:stCxn xmlns:a="http://schemas.openxmlformats.org/drawingml/2006/main" id="60" idx="1"/>
+            <a:endCxn xmlns:a="http://schemas.openxmlformats.org/drawingml/2006/main" id="25" idx="3"/>
           </p:cNvCxnSpPr>
           <p:nvPr/>
         </p:nvCxnSpPr>
         <p:spPr>
           <a:xfrm xmlns:a="http://schemas.openxmlformats.org/drawingml/2006/main" flipH="1">
-            <a:off x="4878388" y="3419475"/>
-            <a:ext cx="3408362" cy="290049"/>
+            <a:off x="5145088" y="3419475"/>
+            <a:ext cx="3141662" cy="500497"/>
           </a:xfrm>
           <a:prstGeom xmlns:a="http://schemas.openxmlformats.org/drawingml/2006/main" prst="straightConnector1">
             <a:avLst/>
@@ -3406,17 +3768,17 @@
       </p:cxnSp>
       <p:cxnSp>
         <p:nvCxnSpPr>
-          <p:cNvPr id="116" name=""/>
+          <p:cNvPr id="128" name=""/>
           <p:cNvCxnSpPr>
-            <a:stCxn xmlns:a="http://schemas.openxmlformats.org/drawingml/2006/main" id="56" idx="1"/>
-            <a:endCxn xmlns:a="http://schemas.openxmlformats.org/drawingml/2006/main" id="48" idx="6"/>
+            <a:stCxn xmlns:a="http://schemas.openxmlformats.org/drawingml/2006/main" id="62" idx="1"/>
+            <a:endCxn xmlns:a="http://schemas.openxmlformats.org/drawingml/2006/main" id="53" idx="6"/>
           </p:cNvCxnSpPr>
           <p:nvPr/>
         </p:nvCxnSpPr>
         <p:spPr>
-          <a:xfrm xmlns:a="http://schemas.openxmlformats.org/drawingml/2006/main" flipH="1">
-            <a:off x="7075487" y="4533900"/>
-            <a:ext cx="1211263" cy="19050"/>
+          <a:xfrm xmlns:a="http://schemas.openxmlformats.org/drawingml/2006/main" flipH="1" flipV="1">
+            <a:off x="7075487" y="4131673"/>
+            <a:ext cx="1211263" cy="402227"/>
           </a:xfrm>
           <a:prstGeom xmlns:a="http://schemas.openxmlformats.org/drawingml/2006/main" prst="straightConnector1">
             <a:avLst/>
@@ -3432,7 +3794,7 @@
     </p:spTree>
     <p:extLst>
       <p:ext uri="{BB962C8B-B14F-4D97-AF65-F5344CB8AC3E}">
-        <p14:creationId xmlns:p14="http://schemas.microsoft.com/office/powerpoint/2010/main" val="625702117"/>
+        <p14:creationId xmlns:p14="http://schemas.microsoft.com/office/powerpoint/2010/main" val="854815285"/>
       </p:ext>
     </p:extLst>
   </p:cSld>

</xml_diff>